<commit_message>
Add case logos and pictograms to startup theory deck
Brand logos from simple-icons and pictograms from react-icons are shown
next to each real-world case.

Co-Authored-By: Claude Opus 5.5 <noreply@anthropic.com>
Claude-Session: https://claude.ai/code/session_01NBQBMDnFYPbNnyPCfpZoie
</commit_message>
<xml_diff>
--- a/startup-theory-lecture/창업이론_강의자료.pptx
+++ b/startup-theory-lecture/창업이론_강의자료.pptx
@@ -126,20 +126,20 @@
   <p:extLst>
     <p:ext uri="{521415D9-36F7-43E2-AB2F-B90AF26B5E84}">
       <p14:sectionLst xmlns:p14="http://schemas.microsoft.com/office/powerpoint/2010/main">
-        <p14:section name="01 창업 실패 이유 설문" id="{e0a9a943-362f-7e87-e1d6-0f5490dcf892}">
+        <p14:section name="01 창업 실패 이유 설문" id="{05fb7ae9-f4d8-d855-6c97-bb68f648a80a}">
           <p14:sldIdLst>
             <p14:sldId id="256"/>
             <p14:sldId id="257"/>
           </p14:sldIdLst>
         </p14:section>
-        <p14:section name="02 실패의 진짜 원인" id="{2136b90a-0ad1-c477-f4a0-26c1e7978b3b}">
+        <p14:section name="02 실패의 진짜 원인" id="{755f0a94-03e6-7b61-e96c-39e30a3b19a7}">
           <p14:sldIdLst>
             <p14:sldId id="258"/>
             <p14:sldId id="259"/>
             <p14:sldId id="260"/>
           </p14:sldIdLst>
         </p14:section>
-        <p14:section name="03 창업 이론의 진화" id="{11931368-1701-2aa3-1ac8-51c4b472b392}">
+        <p14:section name="03 창업 이론의 진화" id="{b052796b-7794-1751-0dc0-59536db9fe3f}">
           <p14:sldIdLst>
             <p14:sldId id="261"/>
             <p14:sldId id="262"/>
@@ -148,32 +148,32 @@
             <p14:sldId id="265"/>
           </p14:sldIdLst>
         </p14:section>
-        <p14:section name="04 졸리 모델" id="{25ff2ab2-80e3-a7cd-9445-8f7c2cf211e0}">
+        <p14:section name="04 졸리 모델" id="{4f9cc936-6927-3648-b7d5-cd68f6d68e41}">
           <p14:sldIdLst>
             <p14:sldId id="266"/>
             <p14:sldId id="267"/>
           </p14:sldIdLst>
         </p14:section>
-        <p14:section name="05 디자인 씽킹" id="{1f14ac09-3581-af06-71d8-b2c1db05be15}">
+        <p14:section name="05 디자인 씽킹" id="{2d9552ad-a401-844e-7de3-351c6f946562}">
           <p14:sldIdLst>
             <p14:sldId id="268"/>
             <p14:sldId id="269"/>
           </p14:sldIdLst>
         </p14:section>
-        <p14:section name="06 BMC vs 린 캔버스" id="{949fa42f-dd9e-fa6b-456a-09e0d10a1c36}">
+        <p14:section name="06 BMC vs 린 캔버스" id="{0ca25f35-c0ac-f171-acb9-8af70acdd75c}">
           <p14:sldIdLst>
             <p14:sldId id="270"/>
             <p14:sldId id="271"/>
             <p14:sldId id="272"/>
           </p14:sldIdLst>
         </p14:section>
-        <p14:section name="07 스타트업 오너스 매뉴얼" id="{0f6cb23a-be2d-fbbe-65b8-b71e84de8988}">
+        <p14:section name="07 스타트업 오너스 매뉴얼" id="{be38fea3-50e2-66a1-194b-2691ade958e0}">
           <p14:sldIdLst>
             <p14:sldId id="273"/>
             <p14:sldId id="274"/>
           </p14:sldIdLst>
         </p14:section>
-        <p14:section name="08 종합" id="{7ba69a4c-3026-54d5-090c-8c62b6d2d8ba}">
+        <p14:section name="08 종합" id="{bff00ba9-e45f-c1e9-ceba-d774662e3cfb}">
           <p14:sldIdLst>
             <p14:sldId id="275"/>
           </p14:sldIdLst>
@@ -3571,14 +3571,65 @@
       </p:sp>
       <p:sp>
         <p:nvSpPr>
-          <p:cNvPr id="11" name="Text 8"/>
+          <p:cNvPr id="11" name="img-frame-juicero"/>
+          <p:cNvSpPr/>
+          <p:nvPr/>
+        </p:nvSpPr>
+        <p:spPr>
+          <a:xfrm>
+            <a:off x="8119872" y="2834640"/>
+            <a:ext cx="566928" cy="566928"/>
+          </a:xfrm>
+          <a:prstGeom prst="roundRect">
+            <a:avLst>
+              <a:gd name="adj" fmla="val 9677"/>
+            </a:avLst>
+          </a:prstGeom>
+          <a:solidFill>
+            <a:schemeClr val="bg1"/>
+          </a:solidFill>
+          <a:ln w="9525">
+            <a:solidFill>
+              <a:schemeClr val="bg2"/>
+            </a:solidFill>
+            <a:prstDash val="solid"/>
+          </a:ln>
+        </p:spPr>
+      </p:sp>
+      <p:pic>
+        <p:nvPicPr>
+          <p:cNvPr id="12" name="img-juicero" descr="juicero">    </p:cNvPr>
+          <p:cNvPicPr>
+            <a:picLocks noChangeAspect="1"/>
+          </p:cNvPicPr>
+          <p:nvPr/>
+        </p:nvPicPr>
+        <p:blipFill>
+          <a:blip r:embed="rId2"/>
+          <a:stretch>
+            <a:fillRect/>
+          </a:stretch>
+        </p:blipFill>
+        <p:spPr>
+          <a:xfrm>
+            <a:off x="8193573" y="2908341"/>
+            <a:ext cx="419527" cy="419527"/>
+          </a:xfrm>
+          <a:prstGeom prst="rect">
+            <a:avLst/>
+          </a:prstGeom>
+        </p:spPr>
+      </p:pic>
+      <p:sp>
+        <p:nvSpPr>
+          <p:cNvPr id="13" name="Text 9"/>
           <p:cNvSpPr txBox="1"/>
           <p:nvPr/>
         </p:nvSpPr>
         <p:spPr>
           <a:xfrm>
             <a:off x="6510528" y="2807208"/>
-            <a:ext cx="2176272" cy="292608"/>
+            <a:ext cx="1499616" cy="292608"/>
           </a:xfrm>
           <a:prstGeom prst="rect">
             <a:avLst/>
@@ -3599,7 +3650,7 @@
                   <a:schemeClr val="accent2"/>
                 </a:solidFill>
               </a:rPr>
-              <a:t>주서로(Juicero), 2017</a:t>
+              <a:t>주서로 (2017)</a:t>
             </a:r>
             <a:endParaRPr lang="en-US" sz="1200" dirty="0"/>
           </a:p>
@@ -3607,14 +3658,14 @@
       </p:sp>
       <p:sp>
         <p:nvSpPr>
-          <p:cNvPr id="12" name="Text 9"/>
+          <p:cNvPr id="14" name="Text 10"/>
           <p:cNvSpPr txBox="1"/>
           <p:nvPr/>
         </p:nvSpPr>
         <p:spPr>
           <a:xfrm>
             <a:off x="5870448" y="3127248"/>
-            <a:ext cx="2798064" cy="1591056"/>
+            <a:ext cx="2121408" cy="1591056"/>
           </a:xfrm>
           <a:prstGeom prst="rect">
             <a:avLst/>
@@ -3683,7 +3734,7 @@
       </p:sp>
       <p:sp>
         <p:nvSpPr>
-          <p:cNvPr id="13" name="Text 10"/>
+          <p:cNvPr id="15" name="Text 11"/>
           <p:cNvSpPr txBox="1"/>
           <p:nvPr/>
         </p:nvSpPr>
@@ -4073,7 +4124,58 @@
       </p:sp>
       <p:sp>
         <p:nvSpPr>
-          <p:cNvPr id="11" name="Text 9"/>
+          <p:cNvPr id="11" name="img-frame-m3"/>
+          <p:cNvSpPr/>
+          <p:nvPr/>
+        </p:nvSpPr>
+        <p:spPr>
+          <a:xfrm>
+            <a:off x="1481328" y="3291840"/>
+            <a:ext cx="402336" cy="402336"/>
+          </a:xfrm>
+          <a:prstGeom prst="roundRect">
+            <a:avLst>
+              <a:gd name="adj" fmla="val 13636"/>
+            </a:avLst>
+          </a:prstGeom>
+          <a:solidFill>
+            <a:schemeClr val="bg1"/>
+          </a:solidFill>
+          <a:ln w="9525">
+            <a:solidFill>
+              <a:schemeClr val="bg2"/>
+            </a:solidFill>
+            <a:prstDash val="solid"/>
+          </a:ln>
+        </p:spPr>
+      </p:sp>
+      <p:pic>
+        <p:nvPicPr>
+          <p:cNvPr id="12" name="img-m3" descr="m3">    </p:cNvPr>
+          <p:cNvPicPr>
+            <a:picLocks noChangeAspect="1"/>
+          </p:cNvPicPr>
+          <p:nvPr/>
+        </p:nvPicPr>
+        <p:blipFill>
+          <a:blip r:embed="rId1"/>
+          <a:stretch>
+            <a:fillRect/>
+          </a:stretch>
+        </p:blipFill>
+        <p:spPr>
+          <a:xfrm>
+            <a:off x="1533632" y="3344144"/>
+            <a:ext cx="297729" cy="297729"/>
+          </a:xfrm>
+          <a:prstGeom prst="rect">
+            <a:avLst/>
+          </a:prstGeom>
+        </p:spPr>
+      </p:pic>
+      <p:sp>
+        <p:nvSpPr>
+          <p:cNvPr id="13" name="Text 10"/>
           <p:cNvSpPr txBox="1"/>
           <p:nvPr/>
         </p:nvSpPr>
@@ -4123,7 +4225,7 @@
       </p:sp>
       <p:sp>
         <p:nvSpPr>
-          <p:cNvPr id="12" name="road-1"/>
+          <p:cNvPr id="14" name="road-1"/>
           <p:cNvSpPr/>
           <p:nvPr/>
         </p:nvSpPr>
@@ -4145,7 +4247,7 @@
       </p:sp>
       <p:sp>
         <p:nvSpPr>
-          <p:cNvPr id="13" name="road-dot-1"/>
+          <p:cNvPr id="15" name="road-dot-1"/>
           <p:cNvSpPr/>
           <p:nvPr/>
         </p:nvSpPr>
@@ -4165,7 +4267,7 @@
       </p:sp>
       <p:sp>
         <p:nvSpPr>
-          <p:cNvPr id="14" name="Text 12"/>
+          <p:cNvPr id="16" name="Text 13"/>
           <p:cNvSpPr txBox="1"/>
           <p:nvPr/>
         </p:nvSpPr>
@@ -4201,7 +4303,7 @@
       </p:sp>
       <p:sp>
         <p:nvSpPr>
-          <p:cNvPr id="15" name="Text 13"/>
+          <p:cNvPr id="17" name="Text 14"/>
           <p:cNvSpPr txBox="1"/>
           <p:nvPr/>
         </p:nvSpPr>
@@ -4237,7 +4339,7 @@
       </p:sp>
       <p:sp>
         <p:nvSpPr>
-          <p:cNvPr id="16" name="Text 14"/>
+          <p:cNvPr id="18" name="Text 15"/>
           <p:cNvSpPr txBox="1"/>
           <p:nvPr/>
         </p:nvSpPr>
@@ -4273,7 +4375,7 @@
       </p:sp>
       <p:sp>
         <p:nvSpPr>
-          <p:cNvPr id="17" name="Text 15"/>
+          <p:cNvPr id="19" name="Text 16"/>
           <p:cNvSpPr txBox="1"/>
           <p:nvPr/>
         </p:nvSpPr>
@@ -4309,7 +4411,7 @@
       </p:sp>
       <p:sp>
         <p:nvSpPr>
-          <p:cNvPr id="18" name="road-case-1"/>
+          <p:cNvPr id="20" name="road-case-1"/>
           <p:cNvSpPr/>
           <p:nvPr/>
         </p:nvSpPr>
@@ -4331,7 +4433,109 @@
       </p:sp>
       <p:sp>
         <p:nvSpPr>
-          <p:cNvPr id="19" name="Text 17"/>
+          <p:cNvPr id="21" name="img-frame-ge"/>
+          <p:cNvSpPr/>
+          <p:nvPr/>
+        </p:nvSpPr>
+        <p:spPr>
+          <a:xfrm>
+            <a:off x="4315968" y="3291840"/>
+            <a:ext cx="402336" cy="402336"/>
+          </a:xfrm>
+          <a:prstGeom prst="roundRect">
+            <a:avLst>
+              <a:gd name="adj" fmla="val 13636"/>
+            </a:avLst>
+          </a:prstGeom>
+          <a:solidFill>
+            <a:schemeClr val="bg1"/>
+          </a:solidFill>
+          <a:ln w="9525">
+            <a:solidFill>
+              <a:schemeClr val="bg2"/>
+            </a:solidFill>
+            <a:prstDash val="solid"/>
+          </a:ln>
+        </p:spPr>
+      </p:sp>
+      <p:pic>
+        <p:nvPicPr>
+          <p:cNvPr id="22" name="img-ge" descr="ge">    </p:cNvPr>
+          <p:cNvPicPr>
+            <a:picLocks noChangeAspect="1"/>
+          </p:cNvPicPr>
+          <p:nvPr/>
+        </p:nvPicPr>
+        <p:blipFill>
+          <a:blip r:embed="rId2"/>
+          <a:stretch>
+            <a:fillRect/>
+          </a:stretch>
+        </p:blipFill>
+        <p:spPr>
+          <a:xfrm>
+            <a:off x="4368272" y="3344144"/>
+            <a:ext cx="297729" cy="297729"/>
+          </a:xfrm>
+          <a:prstGeom prst="rect">
+            <a:avLst/>
+          </a:prstGeom>
+        </p:spPr>
+      </p:pic>
+      <p:sp>
+        <p:nvSpPr>
+          <p:cNvPr id="23" name="img-frame-airbnb"/>
+          <p:cNvSpPr/>
+          <p:nvPr/>
+        </p:nvSpPr>
+        <p:spPr>
+          <a:xfrm>
+            <a:off x="4754880" y="3291840"/>
+            <a:ext cx="402336" cy="402336"/>
+          </a:xfrm>
+          <a:prstGeom prst="roundRect">
+            <a:avLst>
+              <a:gd name="adj" fmla="val 13636"/>
+            </a:avLst>
+          </a:prstGeom>
+          <a:solidFill>
+            <a:schemeClr val="bg1"/>
+          </a:solidFill>
+          <a:ln w="9525">
+            <a:solidFill>
+              <a:schemeClr val="bg2"/>
+            </a:solidFill>
+            <a:prstDash val="solid"/>
+          </a:ln>
+        </p:spPr>
+      </p:sp>
+      <p:pic>
+        <p:nvPicPr>
+          <p:cNvPr id="24" name="img-airbnb" descr="airbnb">    </p:cNvPr>
+          <p:cNvPicPr>
+            <a:picLocks noChangeAspect="1"/>
+          </p:cNvPicPr>
+          <p:nvPr/>
+        </p:nvPicPr>
+        <p:blipFill>
+          <a:blip r:embed="rId3"/>
+          <a:stretch>
+            <a:fillRect/>
+          </a:stretch>
+        </p:blipFill>
+        <p:spPr>
+          <a:xfrm>
+            <a:off x="4807184" y="3344144"/>
+            <a:ext cx="297729" cy="297729"/>
+          </a:xfrm>
+          <a:prstGeom prst="rect">
+            <a:avLst/>
+          </a:prstGeom>
+        </p:spPr>
+      </p:pic>
+      <p:sp>
+        <p:nvSpPr>
+          <p:cNvPr id="25" name="Text 20"/>
           <p:cNvSpPr txBox="1"/>
           <p:nvPr/>
         </p:nvSpPr>
@@ -4381,7 +4585,7 @@
       </p:sp>
       <p:sp>
         <p:nvSpPr>
-          <p:cNvPr id="20" name="road-2"/>
+          <p:cNvPr id="26" name="road-2"/>
           <p:cNvSpPr/>
           <p:nvPr/>
         </p:nvSpPr>
@@ -4403,7 +4607,7 @@
       </p:sp>
       <p:sp>
         <p:nvSpPr>
-          <p:cNvPr id="21" name="road-dot-2"/>
+          <p:cNvPr id="27" name="road-dot-2"/>
           <p:cNvSpPr/>
           <p:nvPr/>
         </p:nvSpPr>
@@ -4423,7 +4627,7 @@
       </p:sp>
       <p:sp>
         <p:nvSpPr>
-          <p:cNvPr id="22" name="Text 20"/>
+          <p:cNvPr id="28" name="Text 23"/>
           <p:cNvSpPr txBox="1"/>
           <p:nvPr/>
         </p:nvSpPr>
@@ -4459,7 +4663,7 @@
       </p:sp>
       <p:sp>
         <p:nvSpPr>
-          <p:cNvPr id="23" name="Text 21"/>
+          <p:cNvPr id="29" name="Text 24"/>
           <p:cNvSpPr txBox="1"/>
           <p:nvPr/>
         </p:nvSpPr>
@@ -4495,7 +4699,7 @@
       </p:sp>
       <p:sp>
         <p:nvSpPr>
-          <p:cNvPr id="24" name="Text 22"/>
+          <p:cNvPr id="30" name="Text 25"/>
           <p:cNvSpPr txBox="1"/>
           <p:nvPr/>
         </p:nvSpPr>
@@ -4545,7 +4749,7 @@
       </p:sp>
       <p:sp>
         <p:nvSpPr>
-          <p:cNvPr id="25" name="Text 23"/>
+          <p:cNvPr id="31" name="Text 26"/>
           <p:cNvSpPr txBox="1"/>
           <p:nvPr/>
         </p:nvSpPr>
@@ -4581,7 +4785,7 @@
       </p:sp>
       <p:sp>
         <p:nvSpPr>
-          <p:cNvPr id="26" name="road-case-2"/>
+          <p:cNvPr id="32" name="road-case-2"/>
           <p:cNvSpPr/>
           <p:nvPr/>
         </p:nvSpPr>
@@ -4603,7 +4807,160 @@
       </p:sp>
       <p:sp>
         <p:nvSpPr>
-          <p:cNvPr id="27" name="Text 25"/>
+          <p:cNvPr id="33" name="img-frame-nespresso"/>
+          <p:cNvSpPr/>
+          <p:nvPr/>
+        </p:nvSpPr>
+        <p:spPr>
+          <a:xfrm>
+            <a:off x="7150608" y="3291840"/>
+            <a:ext cx="402336" cy="402336"/>
+          </a:xfrm>
+          <a:prstGeom prst="roundRect">
+            <a:avLst>
+              <a:gd name="adj" fmla="val 13636"/>
+            </a:avLst>
+          </a:prstGeom>
+          <a:solidFill>
+            <a:schemeClr val="bg1"/>
+          </a:solidFill>
+          <a:ln w="9525">
+            <a:solidFill>
+              <a:schemeClr val="bg2"/>
+            </a:solidFill>
+            <a:prstDash val="solid"/>
+          </a:ln>
+        </p:spPr>
+      </p:sp>
+      <p:pic>
+        <p:nvPicPr>
+          <p:cNvPr id="34" name="img-nespresso" descr="nespresso">    </p:cNvPr>
+          <p:cNvPicPr>
+            <a:picLocks noChangeAspect="1"/>
+          </p:cNvPicPr>
+          <p:nvPr/>
+        </p:nvPicPr>
+        <p:blipFill>
+          <a:blip r:embed="rId4"/>
+          <a:stretch>
+            <a:fillRect/>
+          </a:stretch>
+        </p:blipFill>
+        <p:spPr>
+          <a:xfrm>
+            <a:off x="7202912" y="3344144"/>
+            <a:ext cx="297729" cy="297729"/>
+          </a:xfrm>
+          <a:prstGeom prst="rect">
+            <a:avLst/>
+          </a:prstGeom>
+        </p:spPr>
+      </p:pic>
+      <p:sp>
+        <p:nvSpPr>
+          <p:cNvPr id="35" name="img-frame-uber"/>
+          <p:cNvSpPr/>
+          <p:nvPr/>
+        </p:nvSpPr>
+        <p:spPr>
+          <a:xfrm>
+            <a:off x="7589520" y="3291840"/>
+            <a:ext cx="402336" cy="402336"/>
+          </a:xfrm>
+          <a:prstGeom prst="roundRect">
+            <a:avLst>
+              <a:gd name="adj" fmla="val 13636"/>
+            </a:avLst>
+          </a:prstGeom>
+          <a:solidFill>
+            <a:schemeClr val="bg1"/>
+          </a:solidFill>
+          <a:ln w="9525">
+            <a:solidFill>
+              <a:schemeClr val="bg2"/>
+            </a:solidFill>
+            <a:prstDash val="solid"/>
+          </a:ln>
+        </p:spPr>
+      </p:sp>
+      <p:pic>
+        <p:nvPicPr>
+          <p:cNvPr id="36" name="img-uber" descr="uber">    </p:cNvPr>
+          <p:cNvPicPr>
+            <a:picLocks noChangeAspect="1"/>
+          </p:cNvPicPr>
+          <p:nvPr/>
+        </p:nvPicPr>
+        <p:blipFill>
+          <a:blip r:embed="rId5"/>
+          <a:stretch>
+            <a:fillRect/>
+          </a:stretch>
+        </p:blipFill>
+        <p:spPr>
+          <a:xfrm>
+            <a:off x="7641824" y="3344144"/>
+            <a:ext cx="297729" cy="297729"/>
+          </a:xfrm>
+          <a:prstGeom prst="rect">
+            <a:avLst/>
+          </a:prstGeom>
+        </p:spPr>
+      </p:pic>
+      <p:sp>
+        <p:nvSpPr>
+          <p:cNvPr id="37" name="img-frame-baemin"/>
+          <p:cNvSpPr/>
+          <p:nvPr/>
+        </p:nvSpPr>
+        <p:spPr>
+          <a:xfrm>
+            <a:off x="8028432" y="3291840"/>
+            <a:ext cx="402336" cy="402336"/>
+          </a:xfrm>
+          <a:prstGeom prst="roundRect">
+            <a:avLst>
+              <a:gd name="adj" fmla="val 13636"/>
+            </a:avLst>
+          </a:prstGeom>
+          <a:solidFill>
+            <a:schemeClr val="bg1"/>
+          </a:solidFill>
+          <a:ln w="9525">
+            <a:solidFill>
+              <a:schemeClr val="bg2"/>
+            </a:solidFill>
+            <a:prstDash val="solid"/>
+          </a:ln>
+        </p:spPr>
+      </p:sp>
+      <p:pic>
+        <p:nvPicPr>
+          <p:cNvPr id="38" name="img-baemin" descr="baemin">    </p:cNvPr>
+          <p:cNvPicPr>
+            <a:picLocks noChangeAspect="1"/>
+          </p:cNvPicPr>
+          <p:nvPr/>
+        </p:nvPicPr>
+        <p:blipFill>
+          <a:blip r:embed="rId6"/>
+          <a:stretch>
+            <a:fillRect/>
+          </a:stretch>
+        </p:blipFill>
+        <p:spPr>
+          <a:xfrm>
+            <a:off x="8080736" y="3344144"/>
+            <a:ext cx="297729" cy="297729"/>
+          </a:xfrm>
+          <a:prstGeom prst="rect">
+            <a:avLst/>
+          </a:prstGeom>
+        </p:spPr>
+      </p:pic>
+      <p:sp>
+        <p:nvSpPr>
+          <p:cNvPr id="39" name="Text 31"/>
           <p:cNvSpPr txBox="1"/>
           <p:nvPr/>
         </p:nvSpPr>
@@ -4653,7 +5010,7 @@
       </p:sp>
       <p:sp>
         <p:nvSpPr>
-          <p:cNvPr id="28" name="Text 26"/>
+          <p:cNvPr id="40" name="Text 32"/>
           <p:cNvSpPr txBox="1"/>
           <p:nvPr/>
         </p:nvSpPr>
@@ -5785,14 +6142,65 @@
       </p:sp>
       <p:sp>
         <p:nvSpPr>
-          <p:cNvPr id="31" name="Text 29"/>
+          <p:cNvPr id="31" name="img-frame-factory"/>
+          <p:cNvSpPr/>
+          <p:nvPr/>
+        </p:nvSpPr>
+        <p:spPr>
+          <a:xfrm>
+            <a:off x="8119872" y="4023360"/>
+            <a:ext cx="566928" cy="566928"/>
+          </a:xfrm>
+          <a:prstGeom prst="roundRect">
+            <a:avLst>
+              <a:gd name="adj" fmla="val 9677"/>
+            </a:avLst>
+          </a:prstGeom>
+          <a:solidFill>
+            <a:schemeClr val="bg1"/>
+          </a:solidFill>
+          <a:ln w="9525">
+            <a:solidFill>
+              <a:schemeClr val="bg2"/>
+            </a:solidFill>
+            <a:prstDash val="solid"/>
+          </a:ln>
+        </p:spPr>
+      </p:sp>
+      <p:pic>
+        <p:nvPicPr>
+          <p:cNvPr id="32" name="img-factory" descr="factory">    </p:cNvPr>
+          <p:cNvPicPr>
+            <a:picLocks noChangeAspect="1"/>
+          </p:cNvPicPr>
+          <p:nvPr/>
+        </p:nvPicPr>
+        <p:blipFill>
+          <a:blip r:embed="rId1"/>
+          <a:stretch>
+            <a:fillRect/>
+          </a:stretch>
+        </p:blipFill>
+        <p:spPr>
+          <a:xfrm>
+            <a:off x="8193573" y="4097061"/>
+            <a:ext cx="419527" cy="419527"/>
+          </a:xfrm>
+          <a:prstGeom prst="rect">
+            <a:avLst/>
+          </a:prstGeom>
+        </p:spPr>
+      </p:pic>
+      <p:sp>
+        <p:nvSpPr>
+          <p:cNvPr id="33" name="Text 30"/>
           <p:cNvSpPr txBox="1"/>
           <p:nvPr/>
         </p:nvSpPr>
         <p:spPr>
           <a:xfrm>
             <a:off x="1115568" y="3995928"/>
-            <a:ext cx="7571232" cy="292608"/>
+            <a:ext cx="6894576" cy="292608"/>
           </a:xfrm>
           <a:prstGeom prst="rect">
             <a:avLst/>
@@ -5821,14 +6229,14 @@
       </p:sp>
       <p:sp>
         <p:nvSpPr>
-          <p:cNvPr id="32" name="Text 30"/>
+          <p:cNvPr id="34" name="Text 31"/>
           <p:cNvSpPr txBox="1"/>
           <p:nvPr/>
         </p:nvSpPr>
         <p:spPr>
           <a:xfrm>
             <a:off x="475488" y="4315968"/>
-            <a:ext cx="8193024" cy="402336"/>
+            <a:ext cx="7516368" cy="402336"/>
           </a:xfrm>
           <a:prstGeom prst="rect">
             <a:avLst/>
@@ -5860,7 +6268,7 @@
       </p:sp>
       <p:sp>
         <p:nvSpPr>
-          <p:cNvPr id="33" name="Text 31"/>
+          <p:cNvPr id="35" name="Text 32"/>
           <p:cNvSpPr txBox="1"/>
           <p:nvPr/>
         </p:nvSpPr>
@@ -6917,14 +7325,65 @@
       </p:sp>
       <p:sp>
         <p:nvSpPr>
-          <p:cNvPr id="33" name="Text 31"/>
+          <p:cNvPr id="33" name="img-frame-postit"/>
+          <p:cNvSpPr/>
+          <p:nvPr/>
+        </p:nvSpPr>
+        <p:spPr>
+          <a:xfrm>
+            <a:off x="8119872" y="3657600"/>
+            <a:ext cx="566928" cy="566928"/>
+          </a:xfrm>
+          <a:prstGeom prst="roundRect">
+            <a:avLst>
+              <a:gd name="adj" fmla="val 9677"/>
+            </a:avLst>
+          </a:prstGeom>
+          <a:solidFill>
+            <a:schemeClr val="bg1"/>
+          </a:solidFill>
+          <a:ln w="9525">
+            <a:solidFill>
+              <a:schemeClr val="bg2"/>
+            </a:solidFill>
+            <a:prstDash val="solid"/>
+          </a:ln>
+        </p:spPr>
+      </p:sp>
+      <p:pic>
+        <p:nvPicPr>
+          <p:cNvPr id="34" name="img-postit" descr="postit">    </p:cNvPr>
+          <p:cNvPicPr>
+            <a:picLocks noChangeAspect="1"/>
+          </p:cNvPicPr>
+          <p:nvPr/>
+        </p:nvPicPr>
+        <p:blipFill>
+          <a:blip r:embed="rId1"/>
+          <a:stretch>
+            <a:fillRect/>
+          </a:stretch>
+        </p:blipFill>
+        <p:spPr>
+          <a:xfrm>
+            <a:off x="8193573" y="3731301"/>
+            <a:ext cx="419527" cy="419527"/>
+          </a:xfrm>
+          <a:prstGeom prst="rect">
+            <a:avLst/>
+          </a:prstGeom>
+        </p:spPr>
+      </p:pic>
+      <p:sp>
+        <p:nvSpPr>
+          <p:cNvPr id="35" name="Text 32"/>
           <p:cNvSpPr txBox="1"/>
           <p:nvPr/>
         </p:nvSpPr>
         <p:spPr>
           <a:xfrm>
             <a:off x="1115568" y="3630168"/>
-            <a:ext cx="7571232" cy="292608"/>
+            <a:ext cx="6894576" cy="292608"/>
           </a:xfrm>
           <a:prstGeom prst="rect">
             <a:avLst/>
@@ -6953,14 +7412,14 @@
       </p:sp>
       <p:sp>
         <p:nvSpPr>
-          <p:cNvPr id="34" name="Text 32"/>
+          <p:cNvPr id="36" name="Text 33"/>
           <p:cNvSpPr txBox="1"/>
           <p:nvPr/>
         </p:nvSpPr>
         <p:spPr>
           <a:xfrm>
             <a:off x="475488" y="3950208"/>
-            <a:ext cx="8193024" cy="768096"/>
+            <a:ext cx="7516368" cy="768096"/>
           </a:xfrm>
           <a:prstGeom prst="rect">
             <a:avLst/>
@@ -7029,7 +7488,7 @@
       </p:sp>
       <p:sp>
         <p:nvSpPr>
-          <p:cNvPr id="35" name="Text 33"/>
+          <p:cNvPr id="37" name="Text 34"/>
           <p:cNvSpPr txBox="1"/>
           <p:nvPr/>
         </p:nvSpPr>
@@ -8037,14 +8496,65 @@
       </p:sp>
       <p:sp>
         <p:nvSpPr>
-          <p:cNvPr id="28" name="Text 26"/>
+          <p:cNvPr id="28" name="img-frame-ge"/>
+          <p:cNvSpPr/>
+          <p:nvPr/>
+        </p:nvSpPr>
+        <p:spPr>
+          <a:xfrm>
+            <a:off x="8119872" y="3474720"/>
+            <a:ext cx="566928" cy="566928"/>
+          </a:xfrm>
+          <a:prstGeom prst="roundRect">
+            <a:avLst>
+              <a:gd name="adj" fmla="val 9677"/>
+            </a:avLst>
+          </a:prstGeom>
+          <a:solidFill>
+            <a:schemeClr val="bg1"/>
+          </a:solidFill>
+          <a:ln w="9525">
+            <a:solidFill>
+              <a:schemeClr val="bg2"/>
+            </a:solidFill>
+            <a:prstDash val="solid"/>
+          </a:ln>
+        </p:spPr>
+      </p:sp>
+      <p:pic>
+        <p:nvPicPr>
+          <p:cNvPr id="29" name="img-ge" descr="ge">    </p:cNvPr>
+          <p:cNvPicPr>
+            <a:picLocks noChangeAspect="1"/>
+          </p:cNvPicPr>
+          <p:nvPr/>
+        </p:nvPicPr>
+        <p:blipFill>
+          <a:blip r:embed="rId1"/>
+          <a:stretch>
+            <a:fillRect/>
+          </a:stretch>
+        </p:blipFill>
+        <p:spPr>
+          <a:xfrm>
+            <a:off x="8193573" y="3548421"/>
+            <a:ext cx="419527" cy="419527"/>
+          </a:xfrm>
+          <a:prstGeom prst="rect">
+            <a:avLst/>
+          </a:prstGeom>
+        </p:spPr>
+      </p:pic>
+      <p:sp>
+        <p:nvSpPr>
+          <p:cNvPr id="30" name="Text 27"/>
           <p:cNvSpPr txBox="1"/>
           <p:nvPr/>
         </p:nvSpPr>
         <p:spPr>
           <a:xfrm>
             <a:off x="1115568" y="3447288"/>
-            <a:ext cx="7571232" cy="292608"/>
+            <a:ext cx="6894576" cy="292608"/>
           </a:xfrm>
           <a:prstGeom prst="rect">
             <a:avLst/>
@@ -8073,14 +8583,14 @@
       </p:sp>
       <p:sp>
         <p:nvSpPr>
-          <p:cNvPr id="29" name="Text 27"/>
+          <p:cNvPr id="31" name="Text 28"/>
           <p:cNvSpPr txBox="1"/>
           <p:nvPr/>
         </p:nvSpPr>
         <p:spPr>
           <a:xfrm>
             <a:off x="475488" y="3767328"/>
-            <a:ext cx="8193024" cy="950976"/>
+            <a:ext cx="7516368" cy="950976"/>
           </a:xfrm>
           <a:prstGeom prst="rect">
             <a:avLst/>
@@ -8149,7 +8659,7 @@
       </p:sp>
       <p:sp>
         <p:nvSpPr>
-          <p:cNvPr id="30" name="Text 28"/>
+          <p:cNvPr id="32" name="Text 29"/>
           <p:cNvSpPr txBox="1"/>
           <p:nvPr/>
         </p:nvSpPr>
@@ -9017,14 +9527,65 @@
       </p:sp>
       <p:sp>
         <p:nvSpPr>
-          <p:cNvPr id="28" name="Text 26"/>
+          <p:cNvPr id="28" name="img-frame-airbnb"/>
+          <p:cNvSpPr/>
+          <p:nvPr/>
+        </p:nvSpPr>
+        <p:spPr>
+          <a:xfrm>
+            <a:off x="8119872" y="1645920"/>
+            <a:ext cx="566928" cy="566928"/>
+          </a:xfrm>
+          <a:prstGeom prst="roundRect">
+            <a:avLst>
+              <a:gd name="adj" fmla="val 9677"/>
+            </a:avLst>
+          </a:prstGeom>
+          <a:solidFill>
+            <a:schemeClr val="bg1"/>
+          </a:solidFill>
+          <a:ln w="9525">
+            <a:solidFill>
+              <a:schemeClr val="bg2"/>
+            </a:solidFill>
+            <a:prstDash val="solid"/>
+          </a:ln>
+        </p:spPr>
+      </p:sp>
+      <p:pic>
+        <p:nvPicPr>
+          <p:cNvPr id="29" name="img-airbnb" descr="airbnb">    </p:cNvPr>
+          <p:cNvPicPr>
+            <a:picLocks noChangeAspect="1"/>
+          </p:cNvPicPr>
+          <p:nvPr/>
+        </p:nvPicPr>
+        <p:blipFill>
+          <a:blip r:embed="rId1"/>
+          <a:stretch>
+            <a:fillRect/>
+          </a:stretch>
+        </p:blipFill>
+        <p:spPr>
+          <a:xfrm>
+            <a:off x="8193573" y="1719621"/>
+            <a:ext cx="419527" cy="419527"/>
+          </a:xfrm>
+          <a:prstGeom prst="rect">
+            <a:avLst/>
+          </a:prstGeom>
+        </p:spPr>
+      </p:pic>
+      <p:sp>
+        <p:nvSpPr>
+          <p:cNvPr id="30" name="Text 27"/>
           <p:cNvSpPr txBox="1"/>
           <p:nvPr/>
         </p:nvSpPr>
         <p:spPr>
           <a:xfrm>
             <a:off x="7059168" y="1618488"/>
-            <a:ext cx="1627632" cy="292608"/>
+            <a:ext cx="950976" cy="292608"/>
           </a:xfrm>
           <a:prstGeom prst="rect">
             <a:avLst/>
@@ -9053,14 +9614,14 @@
       </p:sp>
       <p:sp>
         <p:nvSpPr>
-          <p:cNvPr id="29" name="Text 27"/>
+          <p:cNvPr id="31" name="Text 28"/>
           <p:cNvSpPr txBox="1"/>
           <p:nvPr/>
         </p:nvSpPr>
         <p:spPr>
           <a:xfrm>
             <a:off x="6419088" y="1938528"/>
-            <a:ext cx="2249424" cy="2139696"/>
+            <a:ext cx="1572768" cy="2139696"/>
           </a:xfrm>
           <a:prstGeom prst="rect">
             <a:avLst/>
@@ -9143,7 +9704,7 @@
       </p:sp>
       <p:sp>
         <p:nvSpPr>
-          <p:cNvPr id="30" name="Text 28"/>
+          <p:cNvPr id="32" name="Text 29"/>
           <p:cNvSpPr txBox="1"/>
           <p:nvPr/>
         </p:nvSpPr>
@@ -9179,7 +9740,7 @@
       </p:sp>
       <p:sp>
         <p:nvSpPr>
-          <p:cNvPr id="31" name="Text 29"/>
+          <p:cNvPr id="33" name="Text 30"/>
           <p:cNvSpPr txBox="1"/>
           <p:nvPr/>
         </p:nvSpPr>
@@ -10036,7 +10597,58 @@
       </p:sp>
       <p:sp>
         <p:nvSpPr>
-          <p:cNvPr id="22" name="Text 20"/>
+          <p:cNvPr id="22" name="img-frame-nespresso"/>
+          <p:cNvSpPr/>
+          <p:nvPr/>
+        </p:nvSpPr>
+        <p:spPr>
+          <a:xfrm>
+            <a:off x="4206240" y="2651760"/>
+            <a:ext cx="731520" cy="731520"/>
+          </a:xfrm>
+          <a:prstGeom prst="roundRect">
+            <a:avLst>
+              <a:gd name="adj" fmla="val 7500"/>
+            </a:avLst>
+          </a:prstGeom>
+          <a:solidFill>
+            <a:schemeClr val="bg1"/>
+          </a:solidFill>
+          <a:ln w="9525">
+            <a:solidFill>
+              <a:schemeClr val="bg2"/>
+            </a:solidFill>
+            <a:prstDash val="solid"/>
+          </a:ln>
+        </p:spPr>
+      </p:sp>
+      <p:pic>
+        <p:nvPicPr>
+          <p:cNvPr id="23" name="img-nespresso" descr="nespresso">    </p:cNvPr>
+          <p:cNvPicPr>
+            <a:picLocks noChangeAspect="1"/>
+          </p:cNvPicPr>
+          <p:nvPr/>
+        </p:nvPicPr>
+        <p:blipFill>
+          <a:blip r:embed="rId1"/>
+          <a:stretch>
+            <a:fillRect/>
+          </a:stretch>
+        </p:blipFill>
+        <p:spPr>
+          <a:xfrm>
+            <a:off x="4301338" y="2746858"/>
+            <a:ext cx="541325" cy="541325"/>
+          </a:xfrm>
+          <a:prstGeom prst="rect">
+            <a:avLst/>
+          </a:prstGeom>
+        </p:spPr>
+      </p:pic>
+      <p:sp>
+        <p:nvSpPr>
+          <p:cNvPr id="24" name="Text 21"/>
           <p:cNvSpPr txBox="1"/>
           <p:nvPr/>
         </p:nvSpPr>
@@ -10072,7 +10684,7 @@
       </p:sp>
       <p:sp>
         <p:nvSpPr>
-          <p:cNvPr id="23" name="Text 21"/>
+          <p:cNvPr id="25" name="Text 22"/>
           <p:cNvSpPr txBox="1"/>
           <p:nvPr/>
         </p:nvSpPr>
@@ -10971,7 +11583,58 @@
       </p:sp>
       <p:sp>
         <p:nvSpPr>
-          <p:cNvPr id="22" name="Text 20"/>
+          <p:cNvPr id="22" name="img-frame-uber"/>
+          <p:cNvSpPr/>
+          <p:nvPr/>
+        </p:nvSpPr>
+        <p:spPr>
+          <a:xfrm>
+            <a:off x="4206240" y="2651760"/>
+            <a:ext cx="731520" cy="731520"/>
+          </a:xfrm>
+          <a:prstGeom prst="roundRect">
+            <a:avLst>
+              <a:gd name="adj" fmla="val 7500"/>
+            </a:avLst>
+          </a:prstGeom>
+          <a:solidFill>
+            <a:schemeClr val="bg1"/>
+          </a:solidFill>
+          <a:ln w="9525">
+            <a:solidFill>
+              <a:schemeClr val="bg2"/>
+            </a:solidFill>
+            <a:prstDash val="solid"/>
+          </a:ln>
+        </p:spPr>
+      </p:sp>
+      <p:pic>
+        <p:nvPicPr>
+          <p:cNvPr id="23" name="img-uber" descr="uber">    </p:cNvPr>
+          <p:cNvPicPr>
+            <a:picLocks noChangeAspect="1"/>
+          </p:cNvPicPr>
+          <p:nvPr/>
+        </p:nvPicPr>
+        <p:blipFill>
+          <a:blip r:embed="rId1"/>
+          <a:stretch>
+            <a:fillRect/>
+          </a:stretch>
+        </p:blipFill>
+        <p:spPr>
+          <a:xfrm>
+            <a:off x="4301338" y="2746858"/>
+            <a:ext cx="541325" cy="541325"/>
+          </a:xfrm>
+          <a:prstGeom prst="rect">
+            <a:avLst/>
+          </a:prstGeom>
+        </p:spPr>
+      </p:pic>
+      <p:sp>
+        <p:nvSpPr>
+          <p:cNvPr id="24" name="Text 21"/>
           <p:cNvSpPr txBox="1"/>
           <p:nvPr/>
         </p:nvSpPr>
@@ -11007,7 +11670,7 @@
       </p:sp>
       <p:sp>
         <p:nvSpPr>
-          <p:cNvPr id="23" name="Text 21"/>
+          <p:cNvPr id="25" name="Text 22"/>
           <p:cNvSpPr txBox="1"/>
           <p:nvPr/>
         </p:nvSpPr>
@@ -12706,14 +13369,65 @@
       </p:sp>
       <p:sp>
         <p:nvSpPr>
-          <p:cNvPr id="8" name="Text 5"/>
+          <p:cNvPr id="8" name="img-frame-nespresso"/>
+          <p:cNvSpPr/>
+          <p:nvPr/>
+        </p:nvSpPr>
+        <p:spPr>
+          <a:xfrm>
+            <a:off x="3822192" y="3794760"/>
+            <a:ext cx="566928" cy="566928"/>
+          </a:xfrm>
+          <a:prstGeom prst="roundRect">
+            <a:avLst>
+              <a:gd name="adj" fmla="val 9677"/>
+            </a:avLst>
+          </a:prstGeom>
+          <a:solidFill>
+            <a:schemeClr val="bg1"/>
+          </a:solidFill>
+          <a:ln w="9525">
+            <a:solidFill>
+              <a:schemeClr val="bg2"/>
+            </a:solidFill>
+            <a:prstDash val="solid"/>
+          </a:ln>
+        </p:spPr>
+      </p:sp>
+      <p:pic>
+        <p:nvPicPr>
+          <p:cNvPr id="9" name="img-nespresso" descr="nespresso">    </p:cNvPr>
+          <p:cNvPicPr>
+            <a:picLocks noChangeAspect="1"/>
+          </p:cNvPicPr>
+          <p:nvPr/>
+        </p:nvPicPr>
+        <p:blipFill>
+          <a:blip r:embed="rId1"/>
+          <a:stretch>
+            <a:fillRect/>
+          </a:stretch>
+        </p:blipFill>
+        <p:spPr>
+          <a:xfrm>
+            <a:off x="3895893" y="3868461"/>
+            <a:ext cx="419527" cy="419527"/>
+          </a:xfrm>
+          <a:prstGeom prst="rect">
+            <a:avLst/>
+          </a:prstGeom>
+        </p:spPr>
+      </p:pic>
+      <p:sp>
+        <p:nvSpPr>
+          <p:cNvPr id="10" name="Text 6"/>
           <p:cNvSpPr txBox="1"/>
           <p:nvPr/>
         </p:nvSpPr>
         <p:spPr>
           <a:xfrm>
             <a:off x="1115568" y="3767328"/>
-            <a:ext cx="3273552" cy="292608"/>
+            <a:ext cx="2596896" cy="292608"/>
           </a:xfrm>
           <a:prstGeom prst="rect">
             <a:avLst/>
@@ -12742,14 +13456,14 @@
       </p:sp>
       <p:sp>
         <p:nvSpPr>
-          <p:cNvPr id="9" name="Text 6"/>
+          <p:cNvPr id="11" name="Text 7"/>
           <p:cNvSpPr txBox="1"/>
           <p:nvPr/>
         </p:nvSpPr>
         <p:spPr>
           <a:xfrm>
             <a:off x="475488" y="4087368"/>
-            <a:ext cx="3895344" cy="630936"/>
+            <a:ext cx="3218688" cy="630936"/>
           </a:xfrm>
           <a:prstGeom prst="rect">
             <a:avLst/>
@@ -12781,7 +13495,7 @@
       </p:sp>
       <p:sp>
         <p:nvSpPr>
-          <p:cNvPr id="10" name="case-card"/>
+          <p:cNvPr id="12" name="case-card"/>
           <p:cNvSpPr/>
           <p:nvPr/>
         </p:nvSpPr>
@@ -12803,7 +13517,7 @@
       </p:sp>
       <p:sp>
         <p:nvSpPr>
-          <p:cNvPr id="11" name="case-chip"/>
+          <p:cNvPr id="13" name="case-chip"/>
           <p:cNvSpPr/>
           <p:nvPr/>
         </p:nvSpPr>
@@ -12825,7 +13539,7 @@
       </p:sp>
       <p:sp>
         <p:nvSpPr>
-          <p:cNvPr id="12" name="Text 9"/>
+          <p:cNvPr id="14" name="Text 10"/>
           <p:cNvSpPr txBox="1"/>
           <p:nvPr/>
         </p:nvSpPr>
@@ -12861,14 +13575,65 @@
       </p:sp>
       <p:sp>
         <p:nvSpPr>
-          <p:cNvPr id="13" name="Text 10"/>
+          <p:cNvPr id="15" name="img-frame-uber"/>
+          <p:cNvSpPr/>
+          <p:nvPr/>
+        </p:nvSpPr>
+        <p:spPr>
+          <a:xfrm>
+            <a:off x="8119872" y="3794760"/>
+            <a:ext cx="566928" cy="566928"/>
+          </a:xfrm>
+          <a:prstGeom prst="roundRect">
+            <a:avLst>
+              <a:gd name="adj" fmla="val 9677"/>
+            </a:avLst>
+          </a:prstGeom>
+          <a:solidFill>
+            <a:schemeClr val="bg1"/>
+          </a:solidFill>
+          <a:ln w="9525">
+            <a:solidFill>
+              <a:schemeClr val="bg2"/>
+            </a:solidFill>
+            <a:prstDash val="solid"/>
+          </a:ln>
+        </p:spPr>
+      </p:sp>
+      <p:pic>
+        <p:nvPicPr>
+          <p:cNvPr id="16" name="img-uber" descr="uber">    </p:cNvPr>
+          <p:cNvPicPr>
+            <a:picLocks noChangeAspect="1"/>
+          </p:cNvPicPr>
+          <p:nvPr/>
+        </p:nvPicPr>
+        <p:blipFill>
+          <a:blip r:embed="rId2"/>
+          <a:stretch>
+            <a:fillRect/>
+          </a:stretch>
+        </p:blipFill>
+        <p:spPr>
+          <a:xfrm>
+            <a:off x="8193573" y="3868461"/>
+            <a:ext cx="419527" cy="419527"/>
+          </a:xfrm>
+          <a:prstGeom prst="rect">
+            <a:avLst/>
+          </a:prstGeom>
+        </p:spPr>
+      </p:pic>
+      <p:sp>
+        <p:nvSpPr>
+          <p:cNvPr id="17" name="Text 12"/>
           <p:cNvSpPr txBox="1"/>
           <p:nvPr/>
         </p:nvSpPr>
         <p:spPr>
           <a:xfrm>
             <a:off x="5413248" y="3767328"/>
-            <a:ext cx="3273552" cy="292608"/>
+            <a:ext cx="2596896" cy="292608"/>
           </a:xfrm>
           <a:prstGeom prst="rect">
             <a:avLst/>
@@ -12897,14 +13662,14 @@
       </p:sp>
       <p:sp>
         <p:nvSpPr>
-          <p:cNvPr id="14" name="Text 11"/>
+          <p:cNvPr id="18" name="Text 13"/>
           <p:cNvSpPr txBox="1"/>
           <p:nvPr/>
         </p:nvSpPr>
         <p:spPr>
           <a:xfrm>
             <a:off x="4773168" y="4087368"/>
-            <a:ext cx="3895344" cy="630936"/>
+            <a:ext cx="3218688" cy="630936"/>
           </a:xfrm>
           <a:prstGeom prst="rect">
             <a:avLst/>
@@ -12936,7 +13701,7 @@
       </p:sp>
       <p:sp>
         <p:nvSpPr>
-          <p:cNvPr id="15" name="Text 12"/>
+          <p:cNvPr id="19" name="Text 14"/>
           <p:cNvSpPr txBox="1"/>
           <p:nvPr/>
         </p:nvSpPr>
@@ -13810,14 +14575,65 @@
       </p:sp>
       <p:sp>
         <p:nvSpPr>
-          <p:cNvPr id="25" name="Text 23"/>
+          <p:cNvPr id="25" name="img-frame-webvan"/>
+          <p:cNvSpPr/>
+          <p:nvPr/>
+        </p:nvSpPr>
+        <p:spPr>
+          <a:xfrm>
+            <a:off x="8119872" y="3794760"/>
+            <a:ext cx="566928" cy="566928"/>
+          </a:xfrm>
+          <a:prstGeom prst="roundRect">
+            <a:avLst>
+              <a:gd name="adj" fmla="val 9677"/>
+            </a:avLst>
+          </a:prstGeom>
+          <a:solidFill>
+            <a:schemeClr val="bg1"/>
+          </a:solidFill>
+          <a:ln w="9525">
+            <a:solidFill>
+              <a:schemeClr val="bg2"/>
+            </a:solidFill>
+            <a:prstDash val="solid"/>
+          </a:ln>
+        </p:spPr>
+      </p:sp>
+      <p:pic>
+        <p:nvPicPr>
+          <p:cNvPr id="26" name="img-webvan" descr="webvan">    </p:cNvPr>
+          <p:cNvPicPr>
+            <a:picLocks noChangeAspect="1"/>
+          </p:cNvPicPr>
+          <p:nvPr/>
+        </p:nvPicPr>
+        <p:blipFill>
+          <a:blip r:embed="rId1"/>
+          <a:stretch>
+            <a:fillRect/>
+          </a:stretch>
+        </p:blipFill>
+        <p:spPr>
+          <a:xfrm>
+            <a:off x="8193573" y="3868461"/>
+            <a:ext cx="419527" cy="419527"/>
+          </a:xfrm>
+          <a:prstGeom prst="rect">
+            <a:avLst/>
+          </a:prstGeom>
+        </p:spPr>
+      </p:pic>
+      <p:sp>
+        <p:nvSpPr>
+          <p:cNvPr id="27" name="Text 24"/>
           <p:cNvSpPr txBox="1"/>
           <p:nvPr/>
         </p:nvSpPr>
         <p:spPr>
           <a:xfrm>
             <a:off x="1115568" y="3767328"/>
-            <a:ext cx="7571232" cy="292608"/>
+            <a:ext cx="6894576" cy="292608"/>
           </a:xfrm>
           <a:prstGeom prst="rect">
             <a:avLst/>
@@ -13846,14 +14662,14 @@
       </p:sp>
       <p:sp>
         <p:nvSpPr>
-          <p:cNvPr id="26" name="Text 24"/>
+          <p:cNvPr id="28" name="Text 25"/>
           <p:cNvSpPr txBox="1"/>
           <p:nvPr/>
         </p:nvSpPr>
         <p:spPr>
           <a:xfrm>
             <a:off x="475488" y="4087368"/>
-            <a:ext cx="8193024" cy="630936"/>
+            <a:ext cx="7516368" cy="630936"/>
           </a:xfrm>
           <a:prstGeom prst="rect">
             <a:avLst/>
@@ -13885,7 +14701,7 @@
       </p:sp>
       <p:sp>
         <p:nvSpPr>
-          <p:cNvPr id="27" name="Text 25"/>
+          <p:cNvPr id="29" name="Text 26"/>
           <p:cNvSpPr txBox="1"/>
           <p:nvPr/>
         </p:nvSpPr>
@@ -14571,14 +15387,65 @@
       </p:sp>
       <p:sp>
         <p:nvSpPr>
-          <p:cNvPr id="19" name="Text 17"/>
+          <p:cNvPr id="19" name="img-frame-baemin"/>
+          <p:cNvSpPr/>
+          <p:nvPr/>
+        </p:nvSpPr>
+        <p:spPr>
+          <a:xfrm>
+            <a:off x="8119872" y="1325880"/>
+            <a:ext cx="566928" cy="566928"/>
+          </a:xfrm>
+          <a:prstGeom prst="roundRect">
+            <a:avLst>
+              <a:gd name="adj" fmla="val 9677"/>
+            </a:avLst>
+          </a:prstGeom>
+          <a:solidFill>
+            <a:schemeClr val="bg1"/>
+          </a:solidFill>
+          <a:ln w="9525">
+            <a:solidFill>
+              <a:schemeClr val="bg2"/>
+            </a:solidFill>
+            <a:prstDash val="solid"/>
+          </a:ln>
+        </p:spPr>
+      </p:sp>
+      <p:pic>
+        <p:nvPicPr>
+          <p:cNvPr id="20" name="img-baemin" descr="baemin">    </p:cNvPr>
+          <p:cNvPicPr>
+            <a:picLocks noChangeAspect="1"/>
+          </p:cNvPicPr>
+          <p:nvPr/>
+        </p:nvPicPr>
+        <p:blipFill>
+          <a:blip r:embed="rId1"/>
+          <a:stretch>
+            <a:fillRect/>
+          </a:stretch>
+        </p:blipFill>
+        <p:spPr>
+          <a:xfrm>
+            <a:off x="8193573" y="1399581"/>
+            <a:ext cx="419527" cy="419527"/>
+          </a:xfrm>
+          <a:prstGeom prst="rect">
+            <a:avLst/>
+          </a:prstGeom>
+        </p:spPr>
+      </p:pic>
+      <p:sp>
+        <p:nvSpPr>
+          <p:cNvPr id="21" name="Text 18"/>
           <p:cNvSpPr txBox="1"/>
           <p:nvPr/>
         </p:nvSpPr>
         <p:spPr>
           <a:xfrm>
             <a:off x="5321808" y="1298448"/>
-            <a:ext cx="3364992" cy="292608"/>
+            <a:ext cx="2688336" cy="292608"/>
           </a:xfrm>
           <a:prstGeom prst="rect">
             <a:avLst/>
@@ -14607,14 +15474,14 @@
       </p:sp>
       <p:sp>
         <p:nvSpPr>
-          <p:cNvPr id="20" name="Text 18"/>
+          <p:cNvPr id="22" name="Text 19"/>
           <p:cNvSpPr txBox="1"/>
           <p:nvPr/>
         </p:nvSpPr>
         <p:spPr>
           <a:xfrm>
             <a:off x="4681728" y="1618488"/>
-            <a:ext cx="3986784" cy="3099816"/>
+            <a:ext cx="3310128" cy="3099816"/>
           </a:xfrm>
           <a:prstGeom prst="rect">
             <a:avLst/>
@@ -14804,7 +15671,7 @@
       </p:sp>
       <p:sp>
         <p:nvSpPr>
-          <p:cNvPr id="21" name="Text 19"/>
+          <p:cNvPr id="23" name="Text 20"/>
           <p:cNvSpPr txBox="1"/>
           <p:nvPr/>
         </p:nvSpPr>
@@ -14840,7 +15707,7 @@
       </p:sp>
       <p:sp>
         <p:nvSpPr>
-          <p:cNvPr id="22" name="Text 20"/>
+          <p:cNvPr id="24" name="Text 21"/>
           <p:cNvSpPr txBox="1"/>
           <p:nvPr/>
         </p:nvSpPr>
@@ -15658,14 +16525,65 @@
       </p:sp>
       <p:sp>
         <p:nvSpPr>
-          <p:cNvPr id="24" name="Text 22"/>
+          <p:cNvPr id="24" name="img-frame-tada"/>
+          <p:cNvSpPr/>
+          <p:nvPr/>
+        </p:nvSpPr>
+        <p:spPr>
+          <a:xfrm>
+            <a:off x="8119872" y="2880360"/>
+            <a:ext cx="566928" cy="566928"/>
+          </a:xfrm>
+          <a:prstGeom prst="roundRect">
+            <a:avLst>
+              <a:gd name="adj" fmla="val 9677"/>
+            </a:avLst>
+          </a:prstGeom>
+          <a:solidFill>
+            <a:schemeClr val="bg1"/>
+          </a:solidFill>
+          <a:ln w="9525">
+            <a:solidFill>
+              <a:schemeClr val="bg2"/>
+            </a:solidFill>
+            <a:prstDash val="solid"/>
+          </a:ln>
+        </p:spPr>
+      </p:sp>
+      <p:pic>
+        <p:nvPicPr>
+          <p:cNvPr id="25" name="img-tada" descr="tada">    </p:cNvPr>
+          <p:cNvPicPr>
+            <a:picLocks noChangeAspect="1"/>
+          </p:cNvPicPr>
+          <p:nvPr/>
+        </p:nvPicPr>
+        <p:blipFill>
+          <a:blip r:embed="rId1"/>
+          <a:stretch>
+            <a:fillRect/>
+          </a:stretch>
+        </p:blipFill>
+        <p:spPr>
+          <a:xfrm>
+            <a:off x="8193573" y="2954061"/>
+            <a:ext cx="419527" cy="419527"/>
+          </a:xfrm>
+          <a:prstGeom prst="rect">
+            <a:avLst/>
+          </a:prstGeom>
+        </p:spPr>
+      </p:pic>
+      <p:sp>
+        <p:nvSpPr>
+          <p:cNvPr id="26" name="Text 23"/>
           <p:cNvSpPr txBox="1"/>
           <p:nvPr/>
         </p:nvSpPr>
         <p:spPr>
           <a:xfrm>
             <a:off x="5321808" y="2852928"/>
-            <a:ext cx="3364992" cy="292608"/>
+            <a:ext cx="2688336" cy="292608"/>
           </a:xfrm>
           <a:prstGeom prst="rect">
             <a:avLst/>
@@ -15694,14 +16612,14 @@
       </p:sp>
       <p:sp>
         <p:nvSpPr>
-          <p:cNvPr id="25" name="Text 23"/>
+          <p:cNvPr id="27" name="Text 24"/>
           <p:cNvSpPr txBox="1"/>
           <p:nvPr/>
         </p:nvSpPr>
         <p:spPr>
           <a:xfrm>
             <a:off x="4681728" y="3172968"/>
-            <a:ext cx="3986784" cy="1545336"/>
+            <a:ext cx="3310128" cy="1545336"/>
           </a:xfrm>
           <a:prstGeom prst="rect">
             <a:avLst/>
@@ -15770,7 +16688,7 @@
       </p:sp>
       <p:sp>
         <p:nvSpPr>
-          <p:cNvPr id="26" name="Text 24"/>
+          <p:cNvPr id="28" name="Text 25"/>
           <p:cNvSpPr txBox="1"/>
           <p:nvPr/>
         </p:nvSpPr>
@@ -18395,14 +19313,65 @@
       </p:sp>
       <p:sp>
         <p:nvSpPr>
-          <p:cNvPr id="31" name="Text 29"/>
+          <p:cNvPr id="31" name="img-frame-quibi"/>
+          <p:cNvSpPr/>
+          <p:nvPr/>
+        </p:nvSpPr>
+        <p:spPr>
+          <a:xfrm>
+            <a:off x="8119872" y="3858768"/>
+            <a:ext cx="566928" cy="566928"/>
+          </a:xfrm>
+          <a:prstGeom prst="roundRect">
+            <a:avLst>
+              <a:gd name="adj" fmla="val 9677"/>
+            </a:avLst>
+          </a:prstGeom>
+          <a:solidFill>
+            <a:schemeClr val="bg1"/>
+          </a:solidFill>
+          <a:ln w="9525">
+            <a:solidFill>
+              <a:schemeClr val="bg2"/>
+            </a:solidFill>
+            <a:prstDash val="solid"/>
+          </a:ln>
+        </p:spPr>
+      </p:sp>
+      <p:pic>
+        <p:nvPicPr>
+          <p:cNvPr id="32" name="img-quibi" descr="quibi">    </p:cNvPr>
+          <p:cNvPicPr>
+            <a:picLocks noChangeAspect="1"/>
+          </p:cNvPicPr>
+          <p:nvPr/>
+        </p:nvPicPr>
+        <p:blipFill>
+          <a:blip r:embed="rId1"/>
+          <a:stretch>
+            <a:fillRect/>
+          </a:stretch>
+        </p:blipFill>
+        <p:spPr>
+          <a:xfrm>
+            <a:off x="8193573" y="3932469"/>
+            <a:ext cx="419527" cy="419527"/>
+          </a:xfrm>
+          <a:prstGeom prst="rect">
+            <a:avLst/>
+          </a:prstGeom>
+        </p:spPr>
+      </p:pic>
+      <p:sp>
+        <p:nvSpPr>
+          <p:cNvPr id="33" name="Text 30"/>
           <p:cNvSpPr txBox="1"/>
           <p:nvPr/>
         </p:nvSpPr>
         <p:spPr>
           <a:xfrm>
             <a:off x="5413248" y="3831336"/>
-            <a:ext cx="3273552" cy="292608"/>
+            <a:ext cx="2596896" cy="292608"/>
           </a:xfrm>
           <a:prstGeom prst="rect">
             <a:avLst/>
@@ -18431,14 +19400,14 @@
       </p:sp>
       <p:sp>
         <p:nvSpPr>
-          <p:cNvPr id="32" name="Text 30"/>
+          <p:cNvPr id="34" name="Text 31"/>
           <p:cNvSpPr txBox="1"/>
           <p:nvPr/>
         </p:nvSpPr>
         <p:spPr>
           <a:xfrm>
             <a:off x="4773168" y="4151376"/>
-            <a:ext cx="3895344" cy="566928"/>
+            <a:ext cx="3218688" cy="566928"/>
           </a:xfrm>
           <a:prstGeom prst="rect">
             <a:avLst/>
@@ -18470,7 +19439,7 @@
       </p:sp>
       <p:sp>
         <p:nvSpPr>
-          <p:cNvPr id="33" name="Text 31"/>
+          <p:cNvPr id="35" name="Text 32"/>
           <p:cNvSpPr txBox="1"/>
           <p:nvPr/>
         </p:nvSpPr>
@@ -18674,14 +19643,65 @@
       </p:sp>
       <p:sp>
         <p:nvSpPr>
-          <p:cNvPr id="5" name="Text 3"/>
+          <p:cNvPr id="5" name="img-frame-webvan"/>
+          <p:cNvSpPr/>
+          <p:nvPr/>
+        </p:nvSpPr>
+        <p:spPr>
+          <a:xfrm>
+            <a:off x="3886200" y="1325880"/>
+            <a:ext cx="475488" cy="475488"/>
+          </a:xfrm>
+          <a:prstGeom prst="roundRect">
+            <a:avLst>
+              <a:gd name="adj" fmla="val 11538"/>
+            </a:avLst>
+          </a:prstGeom>
+          <a:solidFill>
+            <a:schemeClr val="bg1"/>
+          </a:solidFill>
+          <a:ln w="9525">
+            <a:solidFill>
+              <a:schemeClr val="bg2"/>
+            </a:solidFill>
+            <a:prstDash val="solid"/>
+          </a:ln>
+        </p:spPr>
+      </p:sp>
+      <p:pic>
+        <p:nvPicPr>
+          <p:cNvPr id="6" name="img-webvan" descr="webvan">    </p:cNvPr>
+          <p:cNvPicPr>
+            <a:picLocks noChangeAspect="1"/>
+          </p:cNvPicPr>
+          <p:nvPr/>
+        </p:nvPicPr>
+        <p:blipFill>
+          <a:blip r:embed="rId1"/>
+          <a:stretch>
+            <a:fillRect/>
+          </a:stretch>
+        </p:blipFill>
+        <p:spPr>
+          <a:xfrm>
+            <a:off x="3948013" y="1387693"/>
+            <a:ext cx="351861" cy="351861"/>
+          </a:xfrm>
+          <a:prstGeom prst="rect">
+            <a:avLst/>
+          </a:prstGeom>
+        </p:spPr>
+      </p:pic>
+      <p:sp>
+        <p:nvSpPr>
+          <p:cNvPr id="7" name="Text 4"/>
           <p:cNvSpPr txBox="1"/>
           <p:nvPr/>
         </p:nvSpPr>
         <p:spPr>
           <a:xfrm>
             <a:off x="502920" y="1298448"/>
-            <a:ext cx="3840480" cy="320040"/>
+            <a:ext cx="3291840" cy="320040"/>
           </a:xfrm>
           <a:prstGeom prst="rect">
             <a:avLst/>
@@ -18710,14 +19730,14 @@
       </p:sp>
       <p:sp>
         <p:nvSpPr>
-          <p:cNvPr id="6" name="Text 4"/>
-          <p:cNvSpPr txBox="1"/>
-          <p:nvPr/>
-        </p:nvSpPr>
-        <p:spPr>
-          <a:xfrm>
-            <a:off x="502920" y="1691640"/>
-            <a:ext cx="3840480" cy="2194560"/>
+          <p:cNvPr id="8" name="Text 5"/>
+          <p:cNvSpPr txBox="1"/>
+          <p:nvPr/>
+        </p:nvSpPr>
+        <p:spPr>
+          <a:xfrm>
+            <a:off x="502920" y="1847088"/>
+            <a:ext cx="3840480" cy="2039112"/>
           </a:xfrm>
           <a:prstGeom prst="rect">
             <a:avLst/>
@@ -18804,7 +19824,7 @@
       </p:sp>
       <p:sp>
         <p:nvSpPr>
-          <p:cNvPr id="7" name="zappos"/>
+          <p:cNvPr id="9" name="zappos"/>
           <p:cNvSpPr/>
           <p:nvPr/>
         </p:nvSpPr>
@@ -18826,14 +19846,65 @@
       </p:sp>
       <p:sp>
         <p:nvSpPr>
-          <p:cNvPr id="8" name="Text 6"/>
+          <p:cNvPr id="10" name="img-frame-zappos"/>
+          <p:cNvSpPr/>
+          <p:nvPr/>
+        </p:nvSpPr>
+        <p:spPr>
+          <a:xfrm>
+            <a:off x="8183880" y="1325880"/>
+            <a:ext cx="475488" cy="475488"/>
+          </a:xfrm>
+          <a:prstGeom prst="roundRect">
+            <a:avLst>
+              <a:gd name="adj" fmla="val 11538"/>
+            </a:avLst>
+          </a:prstGeom>
+          <a:solidFill>
+            <a:schemeClr val="bg1"/>
+          </a:solidFill>
+          <a:ln w="9525">
+            <a:solidFill>
+              <a:schemeClr val="bg2"/>
+            </a:solidFill>
+            <a:prstDash val="solid"/>
+          </a:ln>
+        </p:spPr>
+      </p:sp>
+      <p:pic>
+        <p:nvPicPr>
+          <p:cNvPr id="11" name="img-zappos" descr="zappos">    </p:cNvPr>
+          <p:cNvPicPr>
+            <a:picLocks noChangeAspect="1"/>
+          </p:cNvPicPr>
+          <p:nvPr/>
+        </p:nvPicPr>
+        <p:blipFill>
+          <a:blip r:embed="rId2"/>
+          <a:stretch>
+            <a:fillRect/>
+          </a:stretch>
+        </p:blipFill>
+        <p:spPr>
+          <a:xfrm>
+            <a:off x="8245693" y="1387693"/>
+            <a:ext cx="351861" cy="351861"/>
+          </a:xfrm>
+          <a:prstGeom prst="rect">
+            <a:avLst/>
+          </a:prstGeom>
+        </p:spPr>
+      </p:pic>
+      <p:sp>
+        <p:nvSpPr>
+          <p:cNvPr id="12" name="Text 8"/>
           <p:cNvSpPr txBox="1"/>
           <p:nvPr/>
         </p:nvSpPr>
         <p:spPr>
           <a:xfrm>
             <a:off x="4800600" y="1298448"/>
-            <a:ext cx="3840480" cy="320040"/>
+            <a:ext cx="3291840" cy="320040"/>
           </a:xfrm>
           <a:prstGeom prst="rect">
             <a:avLst/>
@@ -18862,14 +19933,14 @@
       </p:sp>
       <p:sp>
         <p:nvSpPr>
-          <p:cNvPr id="9" name="Text 7"/>
-          <p:cNvSpPr txBox="1"/>
-          <p:nvPr/>
-        </p:nvSpPr>
-        <p:spPr>
-          <a:xfrm>
-            <a:off x="4800600" y="1691640"/>
-            <a:ext cx="3840480" cy="2194560"/>
+          <p:cNvPr id="13" name="Text 9"/>
+          <p:cNvSpPr txBox="1"/>
+          <p:nvPr/>
+        </p:nvSpPr>
+        <p:spPr>
+          <a:xfrm>
+            <a:off x="4800600" y="1847088"/>
+            <a:ext cx="3840480" cy="2039112"/>
           </a:xfrm>
           <a:prstGeom prst="rect">
             <a:avLst/>
@@ -18956,7 +20027,7 @@
       </p:sp>
       <p:sp>
         <p:nvSpPr>
-          <p:cNvPr id="10" name="case-card"/>
+          <p:cNvPr id="14" name="case-card"/>
           <p:cNvSpPr/>
           <p:nvPr/>
         </p:nvSpPr>
@@ -18978,7 +20049,7 @@
       </p:sp>
       <p:sp>
         <p:nvSpPr>
-          <p:cNvPr id="11" name="case-chip"/>
+          <p:cNvPr id="15" name="case-chip"/>
           <p:cNvSpPr/>
           <p:nvPr/>
         </p:nvSpPr>
@@ -19000,7 +20071,7 @@
       </p:sp>
       <p:sp>
         <p:nvSpPr>
-          <p:cNvPr id="12" name="Text 10"/>
+          <p:cNvPr id="16" name="Text 12"/>
           <p:cNvSpPr txBox="1"/>
           <p:nvPr/>
         </p:nvSpPr>
@@ -19036,14 +20107,65 @@
       </p:sp>
       <p:sp>
         <p:nvSpPr>
-          <p:cNvPr id="13" name="Text 11"/>
+          <p:cNvPr id="17" name="img-frame-dropbox"/>
+          <p:cNvSpPr/>
+          <p:nvPr/>
+        </p:nvSpPr>
+        <p:spPr>
+          <a:xfrm>
+            <a:off x="8156448" y="4160520"/>
+            <a:ext cx="530352" cy="530352"/>
+          </a:xfrm>
+          <a:prstGeom prst="roundRect">
+            <a:avLst>
+              <a:gd name="adj" fmla="val 10345"/>
+            </a:avLst>
+          </a:prstGeom>
+          <a:solidFill>
+            <a:schemeClr val="bg1"/>
+          </a:solidFill>
+          <a:ln w="9525">
+            <a:solidFill>
+              <a:schemeClr val="bg2"/>
+            </a:solidFill>
+            <a:prstDash val="solid"/>
+          </a:ln>
+        </p:spPr>
+      </p:sp>
+      <p:pic>
+        <p:nvPicPr>
+          <p:cNvPr id="18" name="img-dropbox" descr="dropbox">    </p:cNvPr>
+          <p:cNvPicPr>
+            <a:picLocks noChangeAspect="1"/>
+          </p:cNvPicPr>
+          <p:nvPr/>
+        </p:nvPicPr>
+        <p:blipFill>
+          <a:blip r:embed="rId3"/>
+          <a:stretch>
+            <a:fillRect/>
+          </a:stretch>
+        </p:blipFill>
+        <p:spPr>
+          <a:xfrm>
+            <a:off x="8225394" y="4229466"/>
+            <a:ext cx="392460" cy="392460"/>
+          </a:xfrm>
+          <a:prstGeom prst="rect">
+            <a:avLst/>
+          </a:prstGeom>
+        </p:spPr>
+      </p:pic>
+      <p:sp>
+        <p:nvSpPr>
+          <p:cNvPr id="19" name="Text 14"/>
           <p:cNvSpPr txBox="1"/>
           <p:nvPr/>
         </p:nvSpPr>
         <p:spPr>
           <a:xfrm>
             <a:off x="1115568" y="4133088"/>
-            <a:ext cx="7571232" cy="292608"/>
+            <a:ext cx="6931152" cy="292608"/>
           </a:xfrm>
           <a:prstGeom prst="rect">
             <a:avLst/>
@@ -19072,14 +20194,14 @@
       </p:sp>
       <p:sp>
         <p:nvSpPr>
-          <p:cNvPr id="14" name="Text 12"/>
+          <p:cNvPr id="20" name="Text 15"/>
           <p:cNvSpPr txBox="1"/>
           <p:nvPr/>
         </p:nvSpPr>
         <p:spPr>
           <a:xfrm>
             <a:off x="475488" y="4453128"/>
-            <a:ext cx="8193024" cy="274320"/>
+            <a:ext cx="7552944" cy="274320"/>
           </a:xfrm>
           <a:prstGeom prst="rect">
             <a:avLst/>
@@ -19111,7 +20233,7 @@
       </p:sp>
       <p:sp>
         <p:nvSpPr>
-          <p:cNvPr id="15" name="Text 13"/>
+          <p:cNvPr id="21" name="Text 16"/>
           <p:cNvSpPr txBox="1"/>
           <p:nvPr/>
         </p:nvSpPr>
@@ -19869,14 +20991,65 @@
       </p:sp>
       <p:sp>
         <p:nvSpPr>
-          <p:cNvPr id="21" name="Text 19"/>
+          <p:cNvPr id="21" name="img-frame-nsf"/>
+          <p:cNvSpPr/>
+          <p:nvPr/>
+        </p:nvSpPr>
+        <p:spPr>
+          <a:xfrm>
+            <a:off x="8119872" y="3520440"/>
+            <a:ext cx="566928" cy="566928"/>
+          </a:xfrm>
+          <a:prstGeom prst="roundRect">
+            <a:avLst>
+              <a:gd name="adj" fmla="val 9677"/>
+            </a:avLst>
+          </a:prstGeom>
+          <a:solidFill>
+            <a:schemeClr val="bg1"/>
+          </a:solidFill>
+          <a:ln w="9525">
+            <a:solidFill>
+              <a:schemeClr val="bg2"/>
+            </a:solidFill>
+            <a:prstDash val="solid"/>
+          </a:ln>
+        </p:spPr>
+      </p:sp>
+      <p:pic>
+        <p:nvPicPr>
+          <p:cNvPr id="22" name="img-nsf" descr="nsf">    </p:cNvPr>
+          <p:cNvPicPr>
+            <a:picLocks noChangeAspect="1"/>
+          </p:cNvPicPr>
+          <p:nvPr/>
+        </p:nvPicPr>
+        <p:blipFill>
+          <a:blip r:embed="rId1"/>
+          <a:stretch>
+            <a:fillRect/>
+          </a:stretch>
+        </p:blipFill>
+        <p:spPr>
+          <a:xfrm>
+            <a:off x="8193573" y="3594141"/>
+            <a:ext cx="419527" cy="419527"/>
+          </a:xfrm>
+          <a:prstGeom prst="rect">
+            <a:avLst/>
+          </a:prstGeom>
+        </p:spPr>
+      </p:pic>
+      <p:sp>
+        <p:nvSpPr>
+          <p:cNvPr id="23" name="Text 20"/>
           <p:cNvSpPr txBox="1"/>
           <p:nvPr/>
         </p:nvSpPr>
         <p:spPr>
           <a:xfrm>
             <a:off x="1115568" y="3493008"/>
-            <a:ext cx="7571232" cy="292608"/>
+            <a:ext cx="6894576" cy="292608"/>
           </a:xfrm>
           <a:prstGeom prst="rect">
             <a:avLst/>
@@ -19905,14 +21078,14 @@
       </p:sp>
       <p:sp>
         <p:nvSpPr>
-          <p:cNvPr id="22" name="Text 20"/>
+          <p:cNvPr id="24" name="Text 21"/>
           <p:cNvSpPr txBox="1"/>
           <p:nvPr/>
         </p:nvSpPr>
         <p:spPr>
           <a:xfrm>
             <a:off x="475488" y="3813048"/>
-            <a:ext cx="8193024" cy="905256"/>
+            <a:ext cx="7516368" cy="905256"/>
           </a:xfrm>
           <a:prstGeom prst="rect">
             <a:avLst/>
@@ -19963,7 +21136,7 @@
       </p:sp>
       <p:sp>
         <p:nvSpPr>
-          <p:cNvPr id="23" name="Text 21"/>
+          <p:cNvPr id="25" name="Text 22"/>
           <p:cNvSpPr txBox="1"/>
           <p:nvPr/>
         </p:nvSpPr>
@@ -20439,14 +21612,65 @@
       </p:sp>
       <p:sp>
         <p:nvSpPr>
-          <p:cNvPr id="10" name="Text 8"/>
-          <p:cNvSpPr txBox="1"/>
-          <p:nvPr/>
-        </p:nvSpPr>
-        <p:spPr>
-          <a:xfrm>
-            <a:off x="420624" y="4261104"/>
-            <a:ext cx="2130552" cy="512064"/>
+          <p:cNvPr id="10" name="img-frame-m3"/>
+          <p:cNvSpPr/>
+          <p:nvPr/>
+        </p:nvSpPr>
+        <p:spPr>
+          <a:xfrm>
+            <a:off x="420624" y="4297680"/>
+            <a:ext cx="438912" cy="438912"/>
+          </a:xfrm>
+          <a:prstGeom prst="roundRect">
+            <a:avLst>
+              <a:gd name="adj" fmla="val 12500"/>
+            </a:avLst>
+          </a:prstGeom>
+          <a:solidFill>
+            <a:schemeClr val="bg1"/>
+          </a:solidFill>
+          <a:ln w="9525">
+            <a:solidFill>
+              <a:schemeClr val="bg2"/>
+            </a:solidFill>
+            <a:prstDash val="solid"/>
+          </a:ln>
+        </p:spPr>
+      </p:sp>
+      <p:pic>
+        <p:nvPicPr>
+          <p:cNvPr id="11" name="img-m3" descr="m3">    </p:cNvPr>
+          <p:cNvPicPr>
+            <a:picLocks noChangeAspect="1"/>
+          </p:cNvPicPr>
+          <p:nvPr/>
+        </p:nvPicPr>
+        <p:blipFill>
+          <a:blip r:embed="rId1"/>
+          <a:stretch>
+            <a:fillRect/>
+          </a:stretch>
+        </p:blipFill>
+        <p:spPr>
+          <a:xfrm>
+            <a:off x="477683" y="4354739"/>
+            <a:ext cx="324795" cy="324795"/>
+          </a:xfrm>
+          <a:prstGeom prst="rect">
+            <a:avLst/>
+          </a:prstGeom>
+        </p:spPr>
+      </p:pic>
+      <p:sp>
+        <p:nvSpPr>
+          <p:cNvPr id="12" name="Text 9"/>
+          <p:cNvSpPr txBox="1"/>
+          <p:nvPr/>
+        </p:nvSpPr>
+        <p:spPr>
+          <a:xfrm>
+            <a:off x="914400" y="4261104"/>
+            <a:ext cx="1636776" cy="512064"/>
           </a:xfrm>
           <a:prstGeom prst="rect">
             <a:avLst/>
@@ -20486,7 +21710,7 @@
       </p:sp>
       <p:sp>
         <p:nvSpPr>
-          <p:cNvPr id="11" name="colhead-1"/>
+          <p:cNvPr id="13" name="colhead-1"/>
           <p:cNvSpPr/>
           <p:nvPr/>
         </p:nvSpPr>
@@ -20506,7 +21730,7 @@
       </p:sp>
       <p:sp>
         <p:nvSpPr>
-          <p:cNvPr id="12" name="Text 10"/>
+          <p:cNvPr id="14" name="Text 11"/>
           <p:cNvSpPr txBox="1"/>
           <p:nvPr/>
         </p:nvSpPr>
@@ -20556,7 +21780,7 @@
       </p:sp>
       <p:sp>
         <p:nvSpPr>
-          <p:cNvPr id="13" name="colbody-1"/>
+          <p:cNvPr id="15" name="colbody-1"/>
           <p:cNvSpPr/>
           <p:nvPr/>
         </p:nvSpPr>
@@ -20576,7 +21800,7 @@
       </p:sp>
       <p:sp>
         <p:nvSpPr>
-          <p:cNvPr id="14" name="Text 12"/>
+          <p:cNvPr id="16" name="Text 13"/>
           <p:cNvSpPr txBox="1"/>
           <p:nvPr/>
         </p:nvSpPr>
@@ -20612,7 +21836,7 @@
       </p:sp>
       <p:sp>
         <p:nvSpPr>
-          <p:cNvPr id="15" name="Text 13"/>
+          <p:cNvPr id="17" name="Text 14"/>
           <p:cNvSpPr txBox="1"/>
           <p:nvPr/>
         </p:nvSpPr>
@@ -20727,7 +21951,7 @@
       </p:sp>
       <p:sp>
         <p:nvSpPr>
-          <p:cNvPr id="16" name="colcase-1"/>
+          <p:cNvPr id="18" name="colcase-1"/>
           <p:cNvSpPr/>
           <p:nvPr/>
         </p:nvSpPr>
@@ -20749,14 +21973,65 @@
       </p:sp>
       <p:sp>
         <p:nvSpPr>
-          <p:cNvPr id="17" name="Text 15"/>
-          <p:cNvSpPr txBox="1"/>
-          <p:nvPr/>
-        </p:nvSpPr>
-        <p:spPr>
-          <a:xfrm>
-            <a:off x="2798064" y="4261104"/>
-            <a:ext cx="2130552" cy="512064"/>
+          <p:cNvPr id="19" name="img-frame-airbnb"/>
+          <p:cNvSpPr/>
+          <p:nvPr/>
+        </p:nvSpPr>
+        <p:spPr>
+          <a:xfrm>
+            <a:off x="2798064" y="4297680"/>
+            <a:ext cx="438912" cy="438912"/>
+          </a:xfrm>
+          <a:prstGeom prst="roundRect">
+            <a:avLst>
+              <a:gd name="adj" fmla="val 12500"/>
+            </a:avLst>
+          </a:prstGeom>
+          <a:solidFill>
+            <a:schemeClr val="bg1"/>
+          </a:solidFill>
+          <a:ln w="9525">
+            <a:solidFill>
+              <a:schemeClr val="bg2"/>
+            </a:solidFill>
+            <a:prstDash val="solid"/>
+          </a:ln>
+        </p:spPr>
+      </p:sp>
+      <p:pic>
+        <p:nvPicPr>
+          <p:cNvPr id="20" name="img-airbnb" descr="airbnb">    </p:cNvPr>
+          <p:cNvPicPr>
+            <a:picLocks noChangeAspect="1"/>
+          </p:cNvPicPr>
+          <p:nvPr/>
+        </p:nvPicPr>
+        <p:blipFill>
+          <a:blip r:embed="rId2"/>
+          <a:stretch>
+            <a:fillRect/>
+          </a:stretch>
+        </p:blipFill>
+        <p:spPr>
+          <a:xfrm>
+            <a:off x="2855123" y="4354739"/>
+            <a:ext cx="324795" cy="324795"/>
+          </a:xfrm>
+          <a:prstGeom prst="rect">
+            <a:avLst/>
+          </a:prstGeom>
+        </p:spPr>
+      </p:pic>
+      <p:sp>
+        <p:nvSpPr>
+          <p:cNvPr id="21" name="Text 17"/>
+          <p:cNvSpPr txBox="1"/>
+          <p:nvPr/>
+        </p:nvSpPr>
+        <p:spPr>
+          <a:xfrm>
+            <a:off x="3291840" y="4261104"/>
+            <a:ext cx="1636776" cy="512064"/>
           </a:xfrm>
           <a:prstGeom prst="rect">
             <a:avLst/>
@@ -20796,7 +22071,7 @@
       </p:sp>
       <p:sp>
         <p:nvSpPr>
-          <p:cNvPr id="18" name="colhead-2"/>
+          <p:cNvPr id="22" name="colhead-2"/>
           <p:cNvSpPr/>
           <p:nvPr/>
         </p:nvSpPr>
@@ -20816,7 +22091,7 @@
       </p:sp>
       <p:sp>
         <p:nvSpPr>
-          <p:cNvPr id="19" name="Text 17"/>
+          <p:cNvPr id="23" name="Text 19"/>
           <p:cNvSpPr txBox="1"/>
           <p:nvPr/>
         </p:nvSpPr>
@@ -20866,7 +22141,7 @@
       </p:sp>
       <p:sp>
         <p:nvSpPr>
-          <p:cNvPr id="20" name="colbody-2"/>
+          <p:cNvPr id="24" name="colbody-2"/>
           <p:cNvSpPr/>
           <p:nvPr/>
         </p:nvSpPr>
@@ -20886,7 +22161,7 @@
       </p:sp>
       <p:sp>
         <p:nvSpPr>
-          <p:cNvPr id="21" name="Text 19"/>
+          <p:cNvPr id="25" name="Text 21"/>
           <p:cNvSpPr txBox="1"/>
           <p:nvPr/>
         </p:nvSpPr>
@@ -20922,7 +22197,7 @@
       </p:sp>
       <p:sp>
         <p:nvSpPr>
-          <p:cNvPr id="22" name="Text 20"/>
+          <p:cNvPr id="26" name="Text 22"/>
           <p:cNvSpPr txBox="1"/>
           <p:nvPr/>
         </p:nvSpPr>
@@ -21192,7 +22467,7 @@
       </p:sp>
       <p:sp>
         <p:nvSpPr>
-          <p:cNvPr id="23" name="colcase-2"/>
+          <p:cNvPr id="27" name="colcase-2"/>
           <p:cNvSpPr/>
           <p:nvPr/>
         </p:nvSpPr>
@@ -21214,14 +22489,65 @@
       </p:sp>
       <p:sp>
         <p:nvSpPr>
-          <p:cNvPr id="24" name="Text 22"/>
-          <p:cNvSpPr txBox="1"/>
-          <p:nvPr/>
-        </p:nvSpPr>
-        <p:spPr>
-          <a:xfrm>
-            <a:off x="5175504" y="4261104"/>
-            <a:ext cx="3547872" cy="512064"/>
+          <p:cNvPr id="28" name="img-frame-dropbox"/>
+          <p:cNvSpPr/>
+          <p:nvPr/>
+        </p:nvSpPr>
+        <p:spPr>
+          <a:xfrm>
+            <a:off x="5175504" y="4297680"/>
+            <a:ext cx="438912" cy="438912"/>
+          </a:xfrm>
+          <a:prstGeom prst="roundRect">
+            <a:avLst>
+              <a:gd name="adj" fmla="val 12500"/>
+            </a:avLst>
+          </a:prstGeom>
+          <a:solidFill>
+            <a:schemeClr val="bg1"/>
+          </a:solidFill>
+          <a:ln w="9525">
+            <a:solidFill>
+              <a:schemeClr val="bg2"/>
+            </a:solidFill>
+            <a:prstDash val="solid"/>
+          </a:ln>
+        </p:spPr>
+      </p:sp>
+      <p:pic>
+        <p:nvPicPr>
+          <p:cNvPr id="29" name="img-dropbox" descr="dropbox">    </p:cNvPr>
+          <p:cNvPicPr>
+            <a:picLocks noChangeAspect="1"/>
+          </p:cNvPicPr>
+          <p:nvPr/>
+        </p:nvPicPr>
+        <p:blipFill>
+          <a:blip r:embed="rId3"/>
+          <a:stretch>
+            <a:fillRect/>
+          </a:stretch>
+        </p:blipFill>
+        <p:spPr>
+          <a:xfrm>
+            <a:off x="5232563" y="4354739"/>
+            <a:ext cx="324795" cy="324795"/>
+          </a:xfrm>
+          <a:prstGeom prst="rect">
+            <a:avLst/>
+          </a:prstGeom>
+        </p:spPr>
+      </p:pic>
+      <p:sp>
+        <p:nvSpPr>
+          <p:cNvPr id="30" name="Text 25"/>
+          <p:cNvSpPr txBox="1"/>
+          <p:nvPr/>
+        </p:nvSpPr>
+        <p:spPr>
+          <a:xfrm>
+            <a:off x="5669280" y="4261104"/>
+            <a:ext cx="3054096" cy="512064"/>
           </a:xfrm>
           <a:prstGeom prst="rect">
             <a:avLst/>
@@ -21261,7 +22587,7 @@
       </p:sp>
       <p:sp>
         <p:nvSpPr>
-          <p:cNvPr id="25" name="Text 23"/>
+          <p:cNvPr id="31" name="Text 26"/>
           <p:cNvSpPr txBox="1"/>
           <p:nvPr/>
         </p:nvSpPr>
@@ -21465,14 +22791,65 @@
       </p:sp>
       <p:sp>
         <p:nvSpPr>
-          <p:cNvPr id="5" name="Text 3"/>
+          <p:cNvPr id="5" name="img-frame-nasa"/>
+          <p:cNvSpPr/>
+          <p:nvPr/>
+        </p:nvSpPr>
+        <p:spPr>
+          <a:xfrm>
+            <a:off x="4005072" y="1307592"/>
+            <a:ext cx="402336" cy="402336"/>
+          </a:xfrm>
+          <a:prstGeom prst="roundRect">
+            <a:avLst>
+              <a:gd name="adj" fmla="val 13636"/>
+            </a:avLst>
+          </a:prstGeom>
+          <a:solidFill>
+            <a:schemeClr val="bg1"/>
+          </a:solidFill>
+          <a:ln w="9525">
+            <a:solidFill>
+              <a:schemeClr val="bg2"/>
+            </a:solidFill>
+            <a:prstDash val="solid"/>
+          </a:ln>
+        </p:spPr>
+      </p:sp>
+      <p:pic>
+        <p:nvPicPr>
+          <p:cNvPr id="6" name="img-nasa" descr="nasa">    </p:cNvPr>
+          <p:cNvPicPr>
+            <a:picLocks noChangeAspect="1"/>
+          </p:cNvPicPr>
+          <p:nvPr/>
+        </p:nvPicPr>
+        <p:blipFill>
+          <a:blip r:embed="rId1"/>
+          <a:stretch>
+            <a:fillRect/>
+          </a:stretch>
+        </p:blipFill>
+        <p:spPr>
+          <a:xfrm>
+            <a:off x="4057376" y="1359896"/>
+            <a:ext cx="297729" cy="297729"/>
+          </a:xfrm>
+          <a:prstGeom prst="rect">
+            <a:avLst/>
+          </a:prstGeom>
+        </p:spPr>
+      </p:pic>
+      <p:sp>
+        <p:nvSpPr>
+          <p:cNvPr id="7" name="Text 4"/>
           <p:cNvSpPr txBox="1"/>
           <p:nvPr/>
         </p:nvSpPr>
         <p:spPr>
           <a:xfrm>
             <a:off x="438912" y="1280160"/>
-            <a:ext cx="3968496" cy="292608"/>
+            <a:ext cx="3566160" cy="292608"/>
           </a:xfrm>
           <a:prstGeom prst="rect">
             <a:avLst/>
@@ -21512,14 +22889,14 @@
       </p:sp>
       <p:sp>
         <p:nvSpPr>
-          <p:cNvPr id="6" name="Text 4"/>
+          <p:cNvPr id="8" name="Text 5"/>
           <p:cNvSpPr txBox="1"/>
           <p:nvPr/>
         </p:nvSpPr>
         <p:spPr>
           <a:xfrm>
             <a:off x="438912" y="1563624"/>
-            <a:ext cx="3968496" cy="219456"/>
+            <a:ext cx="3566160" cy="219456"/>
           </a:xfrm>
           <a:prstGeom prst="rect">
             <a:avLst/>
@@ -21548,7 +22925,7 @@
       </p:sp>
       <p:sp>
         <p:nvSpPr>
-          <p:cNvPr id="7" name="Text 5"/>
+          <p:cNvPr id="9" name="Text 6"/>
           <p:cNvSpPr txBox="1"/>
           <p:nvPr/>
         </p:nvSpPr>
@@ -21584,7 +22961,7 @@
       </p:sp>
       <p:sp>
         <p:nvSpPr>
-          <p:cNvPr id="8" name="card-case-0"/>
+          <p:cNvPr id="10" name="card-case-0"/>
           <p:cNvSpPr/>
           <p:nvPr/>
         </p:nvSpPr>
@@ -21606,7 +22983,7 @@
       </p:sp>
       <p:sp>
         <p:nvSpPr>
-          <p:cNvPr id="9" name="Text 7"/>
+          <p:cNvPr id="11" name="Text 8"/>
           <p:cNvSpPr txBox="1"/>
           <p:nvPr/>
         </p:nvSpPr>
@@ -21653,7 +23030,7 @@
       </p:sp>
       <p:sp>
         <p:nvSpPr>
-          <p:cNvPr id="10" name="card-1"/>
+          <p:cNvPr id="12" name="card-1"/>
           <p:cNvSpPr/>
           <p:nvPr/>
         </p:nvSpPr>
@@ -21675,14 +23052,65 @@
       </p:sp>
       <p:sp>
         <p:nvSpPr>
-          <p:cNvPr id="11" name="Text 9"/>
+          <p:cNvPr id="13" name="img-frame-factory"/>
+          <p:cNvSpPr/>
+          <p:nvPr/>
+        </p:nvSpPr>
+        <p:spPr>
+          <a:xfrm>
+            <a:off x="8302752" y="1307592"/>
+            <a:ext cx="402336" cy="402336"/>
+          </a:xfrm>
+          <a:prstGeom prst="roundRect">
+            <a:avLst>
+              <a:gd name="adj" fmla="val 13636"/>
+            </a:avLst>
+          </a:prstGeom>
+          <a:solidFill>
+            <a:schemeClr val="bg1"/>
+          </a:solidFill>
+          <a:ln w="9525">
+            <a:solidFill>
+              <a:schemeClr val="bg2"/>
+            </a:solidFill>
+            <a:prstDash val="solid"/>
+          </a:ln>
+        </p:spPr>
+      </p:sp>
+      <p:pic>
+        <p:nvPicPr>
+          <p:cNvPr id="14" name="img-factory" descr="factory">    </p:cNvPr>
+          <p:cNvPicPr>
+            <a:picLocks noChangeAspect="1"/>
+          </p:cNvPicPr>
+          <p:nvPr/>
+        </p:nvPicPr>
+        <p:blipFill>
+          <a:blip r:embed="rId2"/>
+          <a:stretch>
+            <a:fillRect/>
+          </a:stretch>
+        </p:blipFill>
+        <p:spPr>
+          <a:xfrm>
+            <a:off x="8355056" y="1359896"/>
+            <a:ext cx="297729" cy="297729"/>
+          </a:xfrm>
+          <a:prstGeom prst="rect">
+            <a:avLst/>
+          </a:prstGeom>
+        </p:spPr>
+      </p:pic>
+      <p:sp>
+        <p:nvSpPr>
+          <p:cNvPr id="15" name="Text 11"/>
           <p:cNvSpPr txBox="1"/>
           <p:nvPr/>
         </p:nvSpPr>
         <p:spPr>
           <a:xfrm>
             <a:off x="4736592" y="1280160"/>
-            <a:ext cx="3968496" cy="292608"/>
+            <a:ext cx="3566160" cy="292608"/>
           </a:xfrm>
           <a:prstGeom prst="rect">
             <a:avLst/>
@@ -21722,14 +23150,14 @@
       </p:sp>
       <p:sp>
         <p:nvSpPr>
-          <p:cNvPr id="12" name="Text 10"/>
+          <p:cNvPr id="16" name="Text 12"/>
           <p:cNvSpPr txBox="1"/>
           <p:nvPr/>
         </p:nvSpPr>
         <p:spPr>
           <a:xfrm>
             <a:off x="4736592" y="1563624"/>
-            <a:ext cx="3968496" cy="219456"/>
+            <a:ext cx="3566160" cy="219456"/>
           </a:xfrm>
           <a:prstGeom prst="rect">
             <a:avLst/>
@@ -21758,7 +23186,7 @@
       </p:sp>
       <p:sp>
         <p:nvSpPr>
-          <p:cNvPr id="13" name="Text 11"/>
+          <p:cNvPr id="17" name="Text 13"/>
           <p:cNvSpPr txBox="1"/>
           <p:nvPr/>
         </p:nvSpPr>
@@ -21794,7 +23222,7 @@
       </p:sp>
       <p:sp>
         <p:nvSpPr>
-          <p:cNvPr id="14" name="card-case-1"/>
+          <p:cNvPr id="18" name="card-case-1"/>
           <p:cNvSpPr/>
           <p:nvPr/>
         </p:nvSpPr>
@@ -21816,7 +23244,7 @@
       </p:sp>
       <p:sp>
         <p:nvSpPr>
-          <p:cNvPr id="15" name="Text 13"/>
+          <p:cNvPr id="19" name="Text 15"/>
           <p:cNvSpPr txBox="1"/>
           <p:nvPr/>
         </p:nvSpPr>
@@ -21863,7 +23291,7 @@
       </p:sp>
       <p:sp>
         <p:nvSpPr>
-          <p:cNvPr id="16" name="card-2"/>
+          <p:cNvPr id="20" name="card-2"/>
           <p:cNvSpPr/>
           <p:nvPr/>
         </p:nvSpPr>
@@ -21885,14 +23313,65 @@
       </p:sp>
       <p:sp>
         <p:nvSpPr>
-          <p:cNvPr id="17" name="Text 15"/>
+          <p:cNvPr id="21" name="img-frame-tesla"/>
+          <p:cNvSpPr/>
+          <p:nvPr/>
+        </p:nvSpPr>
+        <p:spPr>
+          <a:xfrm>
+            <a:off x="4005072" y="3154680"/>
+            <a:ext cx="402336" cy="402336"/>
+          </a:xfrm>
+          <a:prstGeom prst="roundRect">
+            <a:avLst>
+              <a:gd name="adj" fmla="val 13636"/>
+            </a:avLst>
+          </a:prstGeom>
+          <a:solidFill>
+            <a:schemeClr val="bg1"/>
+          </a:solidFill>
+          <a:ln w="9525">
+            <a:solidFill>
+              <a:schemeClr val="bg2"/>
+            </a:solidFill>
+            <a:prstDash val="solid"/>
+          </a:ln>
+        </p:spPr>
+      </p:sp>
+      <p:pic>
+        <p:nvPicPr>
+          <p:cNvPr id="22" name="img-tesla" descr="tesla">    </p:cNvPr>
+          <p:cNvPicPr>
+            <a:picLocks noChangeAspect="1"/>
+          </p:cNvPicPr>
+          <p:nvPr/>
+        </p:nvPicPr>
+        <p:blipFill>
+          <a:blip r:embed="rId3"/>
+          <a:stretch>
+            <a:fillRect/>
+          </a:stretch>
+        </p:blipFill>
+        <p:spPr>
+          <a:xfrm>
+            <a:off x="4057376" y="3206984"/>
+            <a:ext cx="297729" cy="297729"/>
+          </a:xfrm>
+          <a:prstGeom prst="rect">
+            <a:avLst/>
+          </a:prstGeom>
+        </p:spPr>
+      </p:pic>
+      <p:sp>
+        <p:nvSpPr>
+          <p:cNvPr id="23" name="Text 18"/>
           <p:cNvSpPr txBox="1"/>
           <p:nvPr/>
         </p:nvSpPr>
         <p:spPr>
           <a:xfrm>
             <a:off x="438912" y="3127248"/>
-            <a:ext cx="3968496" cy="292608"/>
+            <a:ext cx="3566160" cy="292608"/>
           </a:xfrm>
           <a:prstGeom prst="rect">
             <a:avLst/>
@@ -21932,14 +23411,14 @@
       </p:sp>
       <p:sp>
         <p:nvSpPr>
-          <p:cNvPr id="18" name="Text 16"/>
+          <p:cNvPr id="24" name="Text 19"/>
           <p:cNvSpPr txBox="1"/>
           <p:nvPr/>
         </p:nvSpPr>
         <p:spPr>
           <a:xfrm>
             <a:off x="438912" y="3410712"/>
-            <a:ext cx="3968496" cy="219456"/>
+            <a:ext cx="3566160" cy="219456"/>
           </a:xfrm>
           <a:prstGeom prst="rect">
             <a:avLst/>
@@ -21968,7 +23447,7 @@
       </p:sp>
       <p:sp>
         <p:nvSpPr>
-          <p:cNvPr id="19" name="Text 17"/>
+          <p:cNvPr id="25" name="Text 20"/>
           <p:cNvSpPr txBox="1"/>
           <p:nvPr/>
         </p:nvSpPr>
@@ -22004,7 +23483,7 @@
       </p:sp>
       <p:sp>
         <p:nvSpPr>
-          <p:cNvPr id="20" name="card-case-2"/>
+          <p:cNvPr id="26" name="card-case-2"/>
           <p:cNvSpPr/>
           <p:nvPr/>
         </p:nvSpPr>
@@ -22026,7 +23505,7 @@
       </p:sp>
       <p:sp>
         <p:nvSpPr>
-          <p:cNvPr id="21" name="Text 19"/>
+          <p:cNvPr id="27" name="Text 22"/>
           <p:cNvSpPr txBox="1"/>
           <p:nvPr/>
         </p:nvSpPr>
@@ -22073,7 +23552,7 @@
       </p:sp>
       <p:sp>
         <p:nvSpPr>
-          <p:cNvPr id="22" name="card-3"/>
+          <p:cNvPr id="28" name="card-3"/>
           <p:cNvSpPr/>
           <p:nvPr/>
         </p:nvSpPr>
@@ -22095,14 +23574,65 @@
       </p:sp>
       <p:sp>
         <p:nvSpPr>
-          <p:cNvPr id="23" name="Text 21"/>
+          <p:cNvPr id="29" name="img-frame-m3"/>
+          <p:cNvSpPr/>
+          <p:nvPr/>
+        </p:nvSpPr>
+        <p:spPr>
+          <a:xfrm>
+            <a:off x="8302752" y="3154680"/>
+            <a:ext cx="402336" cy="402336"/>
+          </a:xfrm>
+          <a:prstGeom prst="roundRect">
+            <a:avLst>
+              <a:gd name="adj" fmla="val 13636"/>
+            </a:avLst>
+          </a:prstGeom>
+          <a:solidFill>
+            <a:schemeClr val="bg1"/>
+          </a:solidFill>
+          <a:ln w="9525">
+            <a:solidFill>
+              <a:schemeClr val="bg2"/>
+            </a:solidFill>
+            <a:prstDash val="solid"/>
+          </a:ln>
+        </p:spPr>
+      </p:sp>
+      <p:pic>
+        <p:nvPicPr>
+          <p:cNvPr id="30" name="img-m3" descr="m3">    </p:cNvPr>
+          <p:cNvPicPr>
+            <a:picLocks noChangeAspect="1"/>
+          </p:cNvPicPr>
+          <p:nvPr/>
+        </p:nvPicPr>
+        <p:blipFill>
+          <a:blip r:embed="rId4"/>
+          <a:stretch>
+            <a:fillRect/>
+          </a:stretch>
+        </p:blipFill>
+        <p:spPr>
+          <a:xfrm>
+            <a:off x="8355056" y="3206984"/>
+            <a:ext cx="297729" cy="297729"/>
+          </a:xfrm>
+          <a:prstGeom prst="rect">
+            <a:avLst/>
+          </a:prstGeom>
+        </p:spPr>
+      </p:pic>
+      <p:sp>
+        <p:nvSpPr>
+          <p:cNvPr id="31" name="Text 25"/>
           <p:cNvSpPr txBox="1"/>
           <p:nvPr/>
         </p:nvSpPr>
         <p:spPr>
           <a:xfrm>
             <a:off x="4736592" y="3127248"/>
-            <a:ext cx="3968496" cy="292608"/>
+            <a:ext cx="3566160" cy="292608"/>
           </a:xfrm>
           <a:prstGeom prst="rect">
             <a:avLst/>
@@ -22142,14 +23672,14 @@
       </p:sp>
       <p:sp>
         <p:nvSpPr>
-          <p:cNvPr id="24" name="Text 22"/>
+          <p:cNvPr id="32" name="Text 26"/>
           <p:cNvSpPr txBox="1"/>
           <p:nvPr/>
         </p:nvSpPr>
         <p:spPr>
           <a:xfrm>
             <a:off x="4736592" y="3410712"/>
-            <a:ext cx="3968496" cy="219456"/>
+            <a:ext cx="3566160" cy="219456"/>
           </a:xfrm>
           <a:prstGeom prst="rect">
             <a:avLst/>
@@ -22178,7 +23708,7 @@
       </p:sp>
       <p:sp>
         <p:nvSpPr>
-          <p:cNvPr id="25" name="Text 23"/>
+          <p:cNvPr id="33" name="Text 27"/>
           <p:cNvSpPr txBox="1"/>
           <p:nvPr/>
         </p:nvSpPr>
@@ -22214,7 +23744,7 @@
       </p:sp>
       <p:sp>
         <p:nvSpPr>
-          <p:cNvPr id="26" name="card-case-3"/>
+          <p:cNvPr id="34" name="card-case-3"/>
           <p:cNvSpPr/>
           <p:nvPr/>
         </p:nvSpPr>
@@ -22236,7 +23766,7 @@
       </p:sp>
       <p:sp>
         <p:nvSpPr>
-          <p:cNvPr id="27" name="Text 25"/>
+          <p:cNvPr id="35" name="Text 29"/>
           <p:cNvSpPr txBox="1"/>
           <p:nvPr/>
         </p:nvSpPr>
@@ -22283,7 +23813,7 @@
       </p:sp>
       <p:sp>
         <p:nvSpPr>
-          <p:cNvPr id="28" name="Text 26"/>
+          <p:cNvPr id="36" name="Text 30"/>
           <p:cNvSpPr txBox="1"/>
           <p:nvPr/>
         </p:nvSpPr>
@@ -22487,14 +24017,65 @@
       </p:sp>
       <p:sp>
         <p:nvSpPr>
-          <p:cNvPr id="5" name="Text 3"/>
+          <p:cNvPr id="5" name="img-frame-spanx"/>
+          <p:cNvSpPr/>
+          <p:nvPr/>
+        </p:nvSpPr>
+        <p:spPr>
+          <a:xfrm>
+            <a:off x="2572512" y="1307592"/>
+            <a:ext cx="402336" cy="402336"/>
+          </a:xfrm>
+          <a:prstGeom prst="roundRect">
+            <a:avLst>
+              <a:gd name="adj" fmla="val 13636"/>
+            </a:avLst>
+          </a:prstGeom>
+          <a:solidFill>
+            <a:schemeClr val="bg1"/>
+          </a:solidFill>
+          <a:ln w="9525">
+            <a:solidFill>
+              <a:schemeClr val="bg2"/>
+            </a:solidFill>
+            <a:prstDash val="solid"/>
+          </a:ln>
+        </p:spPr>
+      </p:sp>
+      <p:pic>
+        <p:nvPicPr>
+          <p:cNvPr id="6" name="img-spanx" descr="spanx">    </p:cNvPr>
+          <p:cNvPicPr>
+            <a:picLocks noChangeAspect="1"/>
+          </p:cNvPicPr>
+          <p:nvPr/>
+        </p:nvPicPr>
+        <p:blipFill>
+          <a:blip r:embed="rId1"/>
+          <a:stretch>
+            <a:fillRect/>
+          </a:stretch>
+        </p:blipFill>
+        <p:spPr>
+          <a:xfrm>
+            <a:off x="2624816" y="1359896"/>
+            <a:ext cx="297729" cy="297729"/>
+          </a:xfrm>
+          <a:prstGeom prst="rect">
+            <a:avLst/>
+          </a:prstGeom>
+        </p:spPr>
+      </p:pic>
+      <p:sp>
+        <p:nvSpPr>
+          <p:cNvPr id="7" name="Text 4"/>
           <p:cNvSpPr txBox="1"/>
           <p:nvPr/>
         </p:nvSpPr>
         <p:spPr>
           <a:xfrm>
             <a:off x="438912" y="1280160"/>
-            <a:ext cx="2535936" cy="292608"/>
+            <a:ext cx="2133600" cy="457200"/>
           </a:xfrm>
           <a:prstGeom prst="rect">
             <a:avLst/>
@@ -22534,14 +24115,14 @@
       </p:sp>
       <p:sp>
         <p:nvSpPr>
-          <p:cNvPr id="6" name="Text 4"/>
-          <p:cNvSpPr txBox="1"/>
-          <p:nvPr/>
-        </p:nvSpPr>
-        <p:spPr>
-          <a:xfrm>
-            <a:off x="438912" y="1563624"/>
-            <a:ext cx="2535936" cy="219456"/>
+          <p:cNvPr id="8" name="Text 5"/>
+          <p:cNvSpPr txBox="1"/>
+          <p:nvPr/>
+        </p:nvSpPr>
+        <p:spPr>
+          <a:xfrm>
+            <a:off x="438912" y="1728216"/>
+            <a:ext cx="2133600" cy="219456"/>
           </a:xfrm>
           <a:prstGeom prst="rect">
             <a:avLst/>
@@ -22570,14 +24151,14 @@
       </p:sp>
       <p:sp>
         <p:nvSpPr>
-          <p:cNvPr id="7" name="Text 5"/>
-          <p:cNvSpPr txBox="1"/>
-          <p:nvPr/>
-        </p:nvSpPr>
-        <p:spPr>
-          <a:xfrm>
-            <a:off x="438912" y="1783080"/>
-            <a:ext cx="2535936" cy="1554480"/>
+          <p:cNvPr id="9" name="Text 6"/>
+          <p:cNvSpPr txBox="1"/>
+          <p:nvPr/>
+        </p:nvSpPr>
+        <p:spPr>
+          <a:xfrm>
+            <a:off x="438912" y="1947672"/>
+            <a:ext cx="2535936" cy="1463040"/>
           </a:xfrm>
           <a:prstGeom prst="rect">
             <a:avLst/>
@@ -22606,7 +24187,7 @@
       </p:sp>
       <p:sp>
         <p:nvSpPr>
-          <p:cNvPr id="8" name="card-case-0"/>
+          <p:cNvPr id="10" name="card-case-0"/>
           <p:cNvSpPr/>
           <p:nvPr/>
         </p:nvSpPr>
@@ -22628,7 +24209,7 @@
       </p:sp>
       <p:sp>
         <p:nvSpPr>
-          <p:cNvPr id="9" name="Text 7"/>
+          <p:cNvPr id="11" name="Text 8"/>
           <p:cNvSpPr txBox="1"/>
           <p:nvPr/>
         </p:nvSpPr>
@@ -22675,7 +24256,7 @@
       </p:sp>
       <p:sp>
         <p:nvSpPr>
-          <p:cNvPr id="10" name="card-1"/>
+          <p:cNvPr id="12" name="card-1"/>
           <p:cNvSpPr/>
           <p:nvPr/>
         </p:nvSpPr>
@@ -22697,14 +24278,65 @@
       </p:sp>
       <p:sp>
         <p:nvSpPr>
-          <p:cNvPr id="11" name="Text 9"/>
+          <p:cNvPr id="13" name="img-frame-cirque"/>
+          <p:cNvSpPr/>
+          <p:nvPr/>
+        </p:nvSpPr>
+        <p:spPr>
+          <a:xfrm>
+            <a:off x="5437632" y="1307592"/>
+            <a:ext cx="402336" cy="402336"/>
+          </a:xfrm>
+          <a:prstGeom prst="roundRect">
+            <a:avLst>
+              <a:gd name="adj" fmla="val 13636"/>
+            </a:avLst>
+          </a:prstGeom>
+          <a:solidFill>
+            <a:schemeClr val="bg1"/>
+          </a:solidFill>
+          <a:ln w="9525">
+            <a:solidFill>
+              <a:schemeClr val="bg2"/>
+            </a:solidFill>
+            <a:prstDash val="solid"/>
+          </a:ln>
+        </p:spPr>
+      </p:sp>
+      <p:pic>
+        <p:nvPicPr>
+          <p:cNvPr id="14" name="img-cirque" descr="cirque">    </p:cNvPr>
+          <p:cNvPicPr>
+            <a:picLocks noChangeAspect="1"/>
+          </p:cNvPicPr>
+          <p:nvPr/>
+        </p:nvPicPr>
+        <p:blipFill>
+          <a:blip r:embed="rId2"/>
+          <a:stretch>
+            <a:fillRect/>
+          </a:stretch>
+        </p:blipFill>
+        <p:spPr>
+          <a:xfrm>
+            <a:off x="5489936" y="1359896"/>
+            <a:ext cx="297729" cy="297729"/>
+          </a:xfrm>
+          <a:prstGeom prst="rect">
+            <a:avLst/>
+          </a:prstGeom>
+        </p:spPr>
+      </p:pic>
+      <p:sp>
+        <p:nvSpPr>
+          <p:cNvPr id="15" name="Text 11"/>
           <p:cNvSpPr txBox="1"/>
           <p:nvPr/>
         </p:nvSpPr>
         <p:spPr>
           <a:xfrm>
             <a:off x="3304032" y="1280160"/>
-            <a:ext cx="2535936" cy="292608"/>
+            <a:ext cx="2133600" cy="457200"/>
           </a:xfrm>
           <a:prstGeom prst="rect">
             <a:avLst/>
@@ -22744,14 +24376,14 @@
       </p:sp>
       <p:sp>
         <p:nvSpPr>
-          <p:cNvPr id="12" name="Text 10"/>
-          <p:cNvSpPr txBox="1"/>
-          <p:nvPr/>
-        </p:nvSpPr>
-        <p:spPr>
-          <a:xfrm>
-            <a:off x="3304032" y="1563624"/>
-            <a:ext cx="2535936" cy="219456"/>
+          <p:cNvPr id="16" name="Text 12"/>
+          <p:cNvSpPr txBox="1"/>
+          <p:nvPr/>
+        </p:nvSpPr>
+        <p:spPr>
+          <a:xfrm>
+            <a:off x="3304032" y="1728216"/>
+            <a:ext cx="2133600" cy="219456"/>
           </a:xfrm>
           <a:prstGeom prst="rect">
             <a:avLst/>
@@ -22780,14 +24412,14 @@
       </p:sp>
       <p:sp>
         <p:nvSpPr>
-          <p:cNvPr id="13" name="Text 11"/>
-          <p:cNvSpPr txBox="1"/>
-          <p:nvPr/>
-        </p:nvSpPr>
-        <p:spPr>
-          <a:xfrm>
-            <a:off x="3304032" y="1783080"/>
-            <a:ext cx="2535936" cy="1554480"/>
+          <p:cNvPr id="17" name="Text 13"/>
+          <p:cNvSpPr txBox="1"/>
+          <p:nvPr/>
+        </p:nvSpPr>
+        <p:spPr>
+          <a:xfrm>
+            <a:off x="3304032" y="1947672"/>
+            <a:ext cx="2535936" cy="1463040"/>
           </a:xfrm>
           <a:prstGeom prst="rect">
             <a:avLst/>
@@ -22816,7 +24448,7 @@
       </p:sp>
       <p:sp>
         <p:nvSpPr>
-          <p:cNvPr id="14" name="card-case-1"/>
+          <p:cNvPr id="18" name="card-case-1"/>
           <p:cNvSpPr/>
           <p:nvPr/>
         </p:nvSpPr>
@@ -22838,7 +24470,7 @@
       </p:sp>
       <p:sp>
         <p:nvSpPr>
-          <p:cNvPr id="15" name="Text 13"/>
+          <p:cNvPr id="19" name="Text 15"/>
           <p:cNvSpPr txBox="1"/>
           <p:nvPr/>
         </p:nvSpPr>
@@ -22885,7 +24517,7 @@
       </p:sp>
       <p:sp>
         <p:nvSpPr>
-          <p:cNvPr id="16" name="card-2"/>
+          <p:cNvPr id="20" name="card-2"/>
           <p:cNvSpPr/>
           <p:nvPr/>
         </p:nvSpPr>
@@ -22907,14 +24539,65 @@
       </p:sp>
       <p:sp>
         <p:nvSpPr>
-          <p:cNvPr id="17" name="Text 15"/>
+          <p:cNvPr id="21" name="img-frame-ge"/>
+          <p:cNvSpPr/>
+          <p:nvPr/>
+        </p:nvSpPr>
+        <p:spPr>
+          <a:xfrm>
+            <a:off x="8302752" y="1307592"/>
+            <a:ext cx="402336" cy="402336"/>
+          </a:xfrm>
+          <a:prstGeom prst="roundRect">
+            <a:avLst>
+              <a:gd name="adj" fmla="val 13636"/>
+            </a:avLst>
+          </a:prstGeom>
+          <a:solidFill>
+            <a:schemeClr val="bg1"/>
+          </a:solidFill>
+          <a:ln w="9525">
+            <a:solidFill>
+              <a:schemeClr val="bg2"/>
+            </a:solidFill>
+            <a:prstDash val="solid"/>
+          </a:ln>
+        </p:spPr>
+      </p:sp>
+      <p:pic>
+        <p:nvPicPr>
+          <p:cNvPr id="22" name="img-ge" descr="ge">    </p:cNvPr>
+          <p:cNvPicPr>
+            <a:picLocks noChangeAspect="1"/>
+          </p:cNvPicPr>
+          <p:nvPr/>
+        </p:nvPicPr>
+        <p:blipFill>
+          <a:blip r:embed="rId3"/>
+          <a:stretch>
+            <a:fillRect/>
+          </a:stretch>
+        </p:blipFill>
+        <p:spPr>
+          <a:xfrm>
+            <a:off x="8355056" y="1359896"/>
+            <a:ext cx="297729" cy="297729"/>
+          </a:xfrm>
+          <a:prstGeom prst="rect">
+            <a:avLst/>
+          </a:prstGeom>
+        </p:spPr>
+      </p:pic>
+      <p:sp>
+        <p:nvSpPr>
+          <p:cNvPr id="23" name="Text 18"/>
           <p:cNvSpPr txBox="1"/>
           <p:nvPr/>
         </p:nvSpPr>
         <p:spPr>
           <a:xfrm>
             <a:off x="6169152" y="1280160"/>
-            <a:ext cx="2535936" cy="292608"/>
+            <a:ext cx="2133600" cy="457200"/>
           </a:xfrm>
           <a:prstGeom prst="rect">
             <a:avLst/>
@@ -22954,14 +24637,14 @@
       </p:sp>
       <p:sp>
         <p:nvSpPr>
-          <p:cNvPr id="18" name="Text 16"/>
-          <p:cNvSpPr txBox="1"/>
-          <p:nvPr/>
-        </p:nvSpPr>
-        <p:spPr>
-          <a:xfrm>
-            <a:off x="6169152" y="1563624"/>
-            <a:ext cx="2535936" cy="219456"/>
+          <p:cNvPr id="24" name="Text 19"/>
+          <p:cNvSpPr txBox="1"/>
+          <p:nvPr/>
+        </p:nvSpPr>
+        <p:spPr>
+          <a:xfrm>
+            <a:off x="6169152" y="1728216"/>
+            <a:ext cx="2133600" cy="219456"/>
           </a:xfrm>
           <a:prstGeom prst="rect">
             <a:avLst/>
@@ -22982,7 +24665,7 @@
                   <a:schemeClr val="tx1"/>
                 </a:solidFill>
               </a:rPr>
-              <a:t>IDEO · Stanford d.school · T. Brown(2008)</a:t>
+              <a:t>IDEO · d.school · T. Brown</a:t>
             </a:r>
             <a:endParaRPr lang="en-US" sz="900" dirty="0"/>
           </a:p>
@@ -22990,14 +24673,14 @@
       </p:sp>
       <p:sp>
         <p:nvSpPr>
-          <p:cNvPr id="19" name="Text 17"/>
-          <p:cNvSpPr txBox="1"/>
-          <p:nvPr/>
-        </p:nvSpPr>
-        <p:spPr>
-          <a:xfrm>
-            <a:off x="6169152" y="1783080"/>
-            <a:ext cx="2535936" cy="1554480"/>
+          <p:cNvPr id="25" name="Text 20"/>
+          <p:cNvSpPr txBox="1"/>
+          <p:nvPr/>
+        </p:nvSpPr>
+        <p:spPr>
+          <a:xfrm>
+            <a:off x="6169152" y="1947672"/>
+            <a:ext cx="2535936" cy="1463040"/>
           </a:xfrm>
           <a:prstGeom prst="rect">
             <a:avLst/>
@@ -23026,7 +24709,7 @@
       </p:sp>
       <p:sp>
         <p:nvSpPr>
-          <p:cNvPr id="20" name="card-case-2"/>
+          <p:cNvPr id="26" name="card-case-2"/>
           <p:cNvSpPr/>
           <p:nvPr/>
         </p:nvSpPr>
@@ -23048,7 +24731,7 @@
       </p:sp>
       <p:sp>
         <p:nvSpPr>
-          <p:cNvPr id="21" name="Text 19"/>
+          <p:cNvPr id="27" name="Text 22"/>
           <p:cNvSpPr txBox="1"/>
           <p:nvPr/>
         </p:nvSpPr>
@@ -23095,7 +24778,7 @@
       </p:sp>
       <p:sp>
         <p:nvSpPr>
-          <p:cNvPr id="22" name="Text 20"/>
+          <p:cNvPr id="28" name="Text 23"/>
           <p:cNvSpPr txBox="1"/>
           <p:nvPr/>
         </p:nvSpPr>
@@ -23299,14 +24982,65 @@
       </p:sp>
       <p:sp>
         <p:nvSpPr>
-          <p:cNvPr id="5" name="Text 3"/>
+          <p:cNvPr id="5" name="img-frame-nespresso"/>
+          <p:cNvSpPr/>
+          <p:nvPr/>
+        </p:nvSpPr>
+        <p:spPr>
+          <a:xfrm>
+            <a:off x="1856232" y="1280160"/>
+            <a:ext cx="402336" cy="402336"/>
+          </a:xfrm>
+          <a:prstGeom prst="roundRect">
+            <a:avLst>
+              <a:gd name="adj" fmla="val 13636"/>
+            </a:avLst>
+          </a:prstGeom>
+          <a:solidFill>
+            <a:schemeClr val="bg1"/>
+          </a:solidFill>
+          <a:ln w="9525">
+            <a:solidFill>
+              <a:schemeClr val="bg2"/>
+            </a:solidFill>
+            <a:prstDash val="solid"/>
+          </a:ln>
+        </p:spPr>
+      </p:sp>
+      <p:pic>
+        <p:nvPicPr>
+          <p:cNvPr id="6" name="img-nespresso" descr="nespresso">    </p:cNvPr>
+          <p:cNvPicPr>
+            <a:picLocks noChangeAspect="1"/>
+          </p:cNvPicPr>
+          <p:nvPr/>
+        </p:nvPicPr>
+        <p:blipFill>
+          <a:blip r:embed="rId1"/>
+          <a:stretch>
+            <a:fillRect/>
+          </a:stretch>
+        </p:blipFill>
+        <p:spPr>
+          <a:xfrm>
+            <a:off x="1908536" y="1332464"/>
+            <a:ext cx="297729" cy="297729"/>
+          </a:xfrm>
+          <a:prstGeom prst="rect">
+            <a:avLst/>
+          </a:prstGeom>
+        </p:spPr>
+      </p:pic>
+      <p:sp>
+        <p:nvSpPr>
+          <p:cNvPr id="7" name="Text 4"/>
           <p:cNvSpPr txBox="1"/>
           <p:nvPr/>
         </p:nvSpPr>
         <p:spPr>
           <a:xfrm>
             <a:off x="438912" y="1252728"/>
-            <a:ext cx="1819656" cy="411480"/>
+            <a:ext cx="1417320" cy="411480"/>
           </a:xfrm>
           <a:prstGeom prst="rect">
             <a:avLst/>
@@ -23346,14 +25080,14 @@
       </p:sp>
       <p:sp>
         <p:nvSpPr>
-          <p:cNvPr id="6" name="Text 4"/>
+          <p:cNvPr id="8" name="Text 5"/>
           <p:cNvSpPr txBox="1"/>
           <p:nvPr/>
         </p:nvSpPr>
         <p:spPr>
           <a:xfrm>
             <a:off x="438912" y="1655064"/>
-            <a:ext cx="1819656" cy="219456"/>
+            <a:ext cx="1417320" cy="219456"/>
           </a:xfrm>
           <a:prstGeom prst="rect">
             <a:avLst/>
@@ -23382,7 +25116,7 @@
       </p:sp>
       <p:sp>
         <p:nvSpPr>
-          <p:cNvPr id="7" name="Text 5"/>
+          <p:cNvPr id="9" name="Text 6"/>
           <p:cNvSpPr txBox="1"/>
           <p:nvPr/>
         </p:nvSpPr>
@@ -23418,7 +25152,7 @@
       </p:sp>
       <p:sp>
         <p:nvSpPr>
-          <p:cNvPr id="8" name="card-case-0"/>
+          <p:cNvPr id="10" name="card-case-0"/>
           <p:cNvSpPr/>
           <p:nvPr/>
         </p:nvSpPr>
@@ -23440,7 +25174,7 @@
       </p:sp>
       <p:sp>
         <p:nvSpPr>
-          <p:cNvPr id="9" name="Text 7"/>
+          <p:cNvPr id="11" name="Text 8"/>
           <p:cNvSpPr txBox="1"/>
           <p:nvPr/>
         </p:nvSpPr>
@@ -23487,7 +25221,7 @@
       </p:sp>
       <p:sp>
         <p:nvSpPr>
-          <p:cNvPr id="10" name="card-1"/>
+          <p:cNvPr id="12" name="card-1"/>
           <p:cNvSpPr/>
           <p:nvPr/>
         </p:nvSpPr>
@@ -23509,14 +25243,65 @@
       </p:sp>
       <p:sp>
         <p:nvSpPr>
-          <p:cNvPr id="11" name="Text 9"/>
+          <p:cNvPr id="13" name="img-frame-uber"/>
+          <p:cNvSpPr/>
+          <p:nvPr/>
+        </p:nvSpPr>
+        <p:spPr>
+          <a:xfrm>
+            <a:off x="4005072" y="1280160"/>
+            <a:ext cx="402336" cy="402336"/>
+          </a:xfrm>
+          <a:prstGeom prst="roundRect">
+            <a:avLst>
+              <a:gd name="adj" fmla="val 13636"/>
+            </a:avLst>
+          </a:prstGeom>
+          <a:solidFill>
+            <a:schemeClr val="bg1"/>
+          </a:solidFill>
+          <a:ln w="9525">
+            <a:solidFill>
+              <a:schemeClr val="bg2"/>
+            </a:solidFill>
+            <a:prstDash val="solid"/>
+          </a:ln>
+        </p:spPr>
+      </p:sp>
+      <p:pic>
+        <p:nvPicPr>
+          <p:cNvPr id="14" name="img-uber" descr="uber">    </p:cNvPr>
+          <p:cNvPicPr>
+            <a:picLocks noChangeAspect="1"/>
+          </p:cNvPicPr>
+          <p:nvPr/>
+        </p:nvPicPr>
+        <p:blipFill>
+          <a:blip r:embed="rId2"/>
+          <a:stretch>
+            <a:fillRect/>
+          </a:stretch>
+        </p:blipFill>
+        <p:spPr>
+          <a:xfrm>
+            <a:off x="4057376" y="1332464"/>
+            <a:ext cx="297729" cy="297729"/>
+          </a:xfrm>
+          <a:prstGeom prst="rect">
+            <a:avLst/>
+          </a:prstGeom>
+        </p:spPr>
+      </p:pic>
+      <p:sp>
+        <p:nvSpPr>
+          <p:cNvPr id="15" name="Text 11"/>
           <p:cNvSpPr txBox="1"/>
           <p:nvPr/>
         </p:nvSpPr>
         <p:spPr>
           <a:xfrm>
             <a:off x="2587752" y="1252728"/>
-            <a:ext cx="1819656" cy="411480"/>
+            <a:ext cx="1417320" cy="411480"/>
           </a:xfrm>
           <a:prstGeom prst="rect">
             <a:avLst/>
@@ -23556,14 +25341,14 @@
       </p:sp>
       <p:sp>
         <p:nvSpPr>
-          <p:cNvPr id="12" name="Text 10"/>
+          <p:cNvPr id="16" name="Text 12"/>
           <p:cNvSpPr txBox="1"/>
           <p:nvPr/>
         </p:nvSpPr>
         <p:spPr>
           <a:xfrm>
             <a:off x="2587752" y="1655064"/>
-            <a:ext cx="1819656" cy="219456"/>
+            <a:ext cx="1417320" cy="219456"/>
           </a:xfrm>
           <a:prstGeom prst="rect">
             <a:avLst/>
@@ -23592,7 +25377,7 @@
       </p:sp>
       <p:sp>
         <p:nvSpPr>
-          <p:cNvPr id="13" name="Text 11"/>
+          <p:cNvPr id="17" name="Text 13"/>
           <p:cNvSpPr txBox="1"/>
           <p:nvPr/>
         </p:nvSpPr>
@@ -23628,7 +25413,7 @@
       </p:sp>
       <p:sp>
         <p:nvSpPr>
-          <p:cNvPr id="14" name="card-case-1"/>
+          <p:cNvPr id="18" name="card-case-1"/>
           <p:cNvSpPr/>
           <p:nvPr/>
         </p:nvSpPr>
@@ -23650,7 +25435,7 @@
       </p:sp>
       <p:sp>
         <p:nvSpPr>
-          <p:cNvPr id="15" name="Text 13"/>
+          <p:cNvPr id="19" name="Text 15"/>
           <p:cNvSpPr txBox="1"/>
           <p:nvPr/>
         </p:nvSpPr>
@@ -23697,7 +25482,7 @@
       </p:sp>
       <p:sp>
         <p:nvSpPr>
-          <p:cNvPr id="16" name="card-2"/>
+          <p:cNvPr id="20" name="card-2"/>
           <p:cNvSpPr/>
           <p:nvPr/>
         </p:nvSpPr>
@@ -23719,14 +25504,65 @@
       </p:sp>
       <p:sp>
         <p:nvSpPr>
-          <p:cNvPr id="17" name="Text 15"/>
+          <p:cNvPr id="21" name="img-frame-dropbox"/>
+          <p:cNvSpPr/>
+          <p:nvPr/>
+        </p:nvSpPr>
+        <p:spPr>
+          <a:xfrm>
+            <a:off x="6153912" y="1280160"/>
+            <a:ext cx="402336" cy="402336"/>
+          </a:xfrm>
+          <a:prstGeom prst="roundRect">
+            <a:avLst>
+              <a:gd name="adj" fmla="val 13636"/>
+            </a:avLst>
+          </a:prstGeom>
+          <a:solidFill>
+            <a:schemeClr val="bg1"/>
+          </a:solidFill>
+          <a:ln w="9525">
+            <a:solidFill>
+              <a:schemeClr val="bg2"/>
+            </a:solidFill>
+            <a:prstDash val="solid"/>
+          </a:ln>
+        </p:spPr>
+      </p:sp>
+      <p:pic>
+        <p:nvPicPr>
+          <p:cNvPr id="22" name="img-dropbox" descr="dropbox">    </p:cNvPr>
+          <p:cNvPicPr>
+            <a:picLocks noChangeAspect="1"/>
+          </p:cNvPicPr>
+          <p:nvPr/>
+        </p:nvPicPr>
+        <p:blipFill>
+          <a:blip r:embed="rId3"/>
+          <a:stretch>
+            <a:fillRect/>
+          </a:stretch>
+        </p:blipFill>
+        <p:spPr>
+          <a:xfrm>
+            <a:off x="6206216" y="1332464"/>
+            <a:ext cx="297729" cy="297729"/>
+          </a:xfrm>
+          <a:prstGeom prst="rect">
+            <a:avLst/>
+          </a:prstGeom>
+        </p:spPr>
+      </p:pic>
+      <p:sp>
+        <p:nvSpPr>
+          <p:cNvPr id="23" name="Text 18"/>
           <p:cNvSpPr txBox="1"/>
           <p:nvPr/>
         </p:nvSpPr>
         <p:spPr>
           <a:xfrm>
             <a:off x="4736592" y="1252728"/>
-            <a:ext cx="1819656" cy="411480"/>
+            <a:ext cx="1417320" cy="411480"/>
           </a:xfrm>
           <a:prstGeom prst="rect">
             <a:avLst/>
@@ -23766,14 +25602,14 @@
       </p:sp>
       <p:sp>
         <p:nvSpPr>
-          <p:cNvPr id="18" name="Text 16"/>
+          <p:cNvPr id="24" name="Text 19"/>
           <p:cNvSpPr txBox="1"/>
           <p:nvPr/>
         </p:nvSpPr>
         <p:spPr>
           <a:xfrm>
             <a:off x="4736592" y="1655064"/>
-            <a:ext cx="1819656" cy="219456"/>
+            <a:ext cx="1417320" cy="219456"/>
           </a:xfrm>
           <a:prstGeom prst="rect">
             <a:avLst/>
@@ -23802,7 +25638,7 @@
       </p:sp>
       <p:sp>
         <p:nvSpPr>
-          <p:cNvPr id="19" name="Text 17"/>
+          <p:cNvPr id="25" name="Text 20"/>
           <p:cNvSpPr txBox="1"/>
           <p:nvPr/>
         </p:nvSpPr>
@@ -23838,7 +25674,7 @@
       </p:sp>
       <p:sp>
         <p:nvSpPr>
-          <p:cNvPr id="20" name="card-case-2"/>
+          <p:cNvPr id="26" name="card-case-2"/>
           <p:cNvSpPr/>
           <p:nvPr/>
         </p:nvSpPr>
@@ -23860,7 +25696,7 @@
       </p:sp>
       <p:sp>
         <p:nvSpPr>
-          <p:cNvPr id="21" name="Text 19"/>
+          <p:cNvPr id="27" name="Text 22"/>
           <p:cNvSpPr txBox="1"/>
           <p:nvPr/>
         </p:nvSpPr>
@@ -23907,7 +25743,7 @@
       </p:sp>
       <p:sp>
         <p:nvSpPr>
-          <p:cNvPr id="22" name="card-3"/>
+          <p:cNvPr id="28" name="card-3"/>
           <p:cNvSpPr/>
           <p:nvPr/>
         </p:nvSpPr>
@@ -23929,14 +25765,65 @@
       </p:sp>
       <p:sp>
         <p:nvSpPr>
-          <p:cNvPr id="23" name="Text 21"/>
+          <p:cNvPr id="29" name="img-frame-nsf"/>
+          <p:cNvSpPr/>
+          <p:nvPr/>
+        </p:nvSpPr>
+        <p:spPr>
+          <a:xfrm>
+            <a:off x="8302752" y="1280160"/>
+            <a:ext cx="402336" cy="402336"/>
+          </a:xfrm>
+          <a:prstGeom prst="roundRect">
+            <a:avLst>
+              <a:gd name="adj" fmla="val 13636"/>
+            </a:avLst>
+          </a:prstGeom>
+          <a:solidFill>
+            <a:schemeClr val="bg1"/>
+          </a:solidFill>
+          <a:ln w="9525">
+            <a:solidFill>
+              <a:schemeClr val="bg2"/>
+            </a:solidFill>
+            <a:prstDash val="solid"/>
+          </a:ln>
+        </p:spPr>
+      </p:sp>
+      <p:pic>
+        <p:nvPicPr>
+          <p:cNvPr id="30" name="img-nsf" descr="nsf">    </p:cNvPr>
+          <p:cNvPicPr>
+            <a:picLocks noChangeAspect="1"/>
+          </p:cNvPicPr>
+          <p:nvPr/>
+        </p:nvPicPr>
+        <p:blipFill>
+          <a:blip r:embed="rId4"/>
+          <a:stretch>
+            <a:fillRect/>
+          </a:stretch>
+        </p:blipFill>
+        <p:spPr>
+          <a:xfrm>
+            <a:off x="8355056" y="1332464"/>
+            <a:ext cx="297729" cy="297729"/>
+          </a:xfrm>
+          <a:prstGeom prst="rect">
+            <a:avLst/>
+          </a:prstGeom>
+        </p:spPr>
+      </p:pic>
+      <p:sp>
+        <p:nvSpPr>
+          <p:cNvPr id="31" name="Text 25"/>
           <p:cNvSpPr txBox="1"/>
           <p:nvPr/>
         </p:nvSpPr>
         <p:spPr>
           <a:xfrm>
             <a:off x="6885432" y="1252728"/>
-            <a:ext cx="1819656" cy="411480"/>
+            <a:ext cx="1417320" cy="411480"/>
           </a:xfrm>
           <a:prstGeom prst="rect">
             <a:avLst/>
@@ -23976,14 +25863,14 @@
       </p:sp>
       <p:sp>
         <p:nvSpPr>
-          <p:cNvPr id="24" name="Text 22"/>
+          <p:cNvPr id="32" name="Text 26"/>
           <p:cNvSpPr txBox="1"/>
           <p:nvPr/>
         </p:nvSpPr>
         <p:spPr>
           <a:xfrm>
             <a:off x="6885432" y="1655064"/>
-            <a:ext cx="1819656" cy="219456"/>
+            <a:ext cx="1417320" cy="219456"/>
           </a:xfrm>
           <a:prstGeom prst="rect">
             <a:avLst/>
@@ -24012,7 +25899,7 @@
       </p:sp>
       <p:sp>
         <p:nvSpPr>
-          <p:cNvPr id="25" name="Text 23"/>
+          <p:cNvPr id="33" name="Text 27"/>
           <p:cNvSpPr txBox="1"/>
           <p:nvPr/>
         </p:nvSpPr>
@@ -24048,7 +25935,7 @@
       </p:sp>
       <p:sp>
         <p:nvSpPr>
-          <p:cNvPr id="26" name="card-case-3"/>
+          <p:cNvPr id="34" name="card-case-3"/>
           <p:cNvSpPr/>
           <p:nvPr/>
         </p:nvSpPr>
@@ -24070,7 +25957,7 @@
       </p:sp>
       <p:sp>
         <p:nvSpPr>
-          <p:cNvPr id="27" name="Text 25"/>
+          <p:cNvPr id="35" name="Text 29"/>
           <p:cNvSpPr txBox="1"/>
           <p:nvPr/>
         </p:nvSpPr>
@@ -24117,7 +26004,7 @@
       </p:sp>
       <p:sp>
         <p:nvSpPr>
-          <p:cNvPr id="28" name="card-4"/>
+          <p:cNvPr id="36" name="card-4"/>
           <p:cNvSpPr/>
           <p:nvPr/>
         </p:nvSpPr>
@@ -24139,14 +26026,65 @@
       </p:sp>
       <p:sp>
         <p:nvSpPr>
-          <p:cNvPr id="29" name="Text 27"/>
+          <p:cNvPr id="37" name="img-frame-mit"/>
+          <p:cNvSpPr/>
+          <p:nvPr/>
+        </p:nvSpPr>
+        <p:spPr>
+          <a:xfrm>
+            <a:off x="1856232" y="3163824"/>
+            <a:ext cx="402336" cy="402336"/>
+          </a:xfrm>
+          <a:prstGeom prst="roundRect">
+            <a:avLst>
+              <a:gd name="adj" fmla="val 13636"/>
+            </a:avLst>
+          </a:prstGeom>
+          <a:solidFill>
+            <a:schemeClr val="bg1"/>
+          </a:solidFill>
+          <a:ln w="9525">
+            <a:solidFill>
+              <a:schemeClr val="bg2"/>
+            </a:solidFill>
+            <a:prstDash val="solid"/>
+          </a:ln>
+        </p:spPr>
+      </p:sp>
+      <p:pic>
+        <p:nvPicPr>
+          <p:cNvPr id="38" name="img-mit" descr="mit">    </p:cNvPr>
+          <p:cNvPicPr>
+            <a:picLocks noChangeAspect="1"/>
+          </p:cNvPicPr>
+          <p:nvPr/>
+        </p:nvPicPr>
+        <p:blipFill>
+          <a:blip r:embed="rId5"/>
+          <a:stretch>
+            <a:fillRect/>
+          </a:stretch>
+        </p:blipFill>
+        <p:spPr>
+          <a:xfrm>
+            <a:off x="1908536" y="3216128"/>
+            <a:ext cx="297729" cy="297729"/>
+          </a:xfrm>
+          <a:prstGeom prst="rect">
+            <a:avLst/>
+          </a:prstGeom>
+        </p:spPr>
+      </p:pic>
+      <p:sp>
+        <p:nvSpPr>
+          <p:cNvPr id="39" name="Text 32"/>
           <p:cNvSpPr txBox="1"/>
           <p:nvPr/>
         </p:nvSpPr>
         <p:spPr>
           <a:xfrm>
             <a:off x="438912" y="3136392"/>
-            <a:ext cx="1819656" cy="411480"/>
+            <a:ext cx="1417320" cy="411480"/>
           </a:xfrm>
           <a:prstGeom prst="rect">
             <a:avLst/>
@@ -24186,14 +26124,14 @@
       </p:sp>
       <p:sp>
         <p:nvSpPr>
-          <p:cNvPr id="30" name="Text 28"/>
+          <p:cNvPr id="40" name="Text 33"/>
           <p:cNvSpPr txBox="1"/>
           <p:nvPr/>
         </p:nvSpPr>
         <p:spPr>
           <a:xfrm>
             <a:off x="438912" y="3538728"/>
-            <a:ext cx="1819656" cy="219456"/>
+            <a:ext cx="1417320" cy="219456"/>
           </a:xfrm>
           <a:prstGeom prst="rect">
             <a:avLst/>
@@ -24222,7 +26160,7 @@
       </p:sp>
       <p:sp>
         <p:nvSpPr>
-          <p:cNvPr id="31" name="Text 29"/>
+          <p:cNvPr id="41" name="Text 34"/>
           <p:cNvSpPr txBox="1"/>
           <p:nvPr/>
         </p:nvSpPr>
@@ -24258,7 +26196,7 @@
       </p:sp>
       <p:sp>
         <p:nvSpPr>
-          <p:cNvPr id="32" name="card-case-4"/>
+          <p:cNvPr id="42" name="card-case-4"/>
           <p:cNvSpPr/>
           <p:nvPr/>
         </p:nvSpPr>
@@ -24280,7 +26218,7 @@
       </p:sp>
       <p:sp>
         <p:nvSpPr>
-          <p:cNvPr id="33" name="Text 31"/>
+          <p:cNvPr id="43" name="Text 36"/>
           <p:cNvSpPr txBox="1"/>
           <p:nvPr/>
         </p:nvSpPr>
@@ -24327,7 +26265,7 @@
       </p:sp>
       <p:sp>
         <p:nvSpPr>
-          <p:cNvPr id="34" name="card-5"/>
+          <p:cNvPr id="44" name="card-5"/>
           <p:cNvSpPr/>
           <p:nvPr/>
         </p:nvSpPr>
@@ -24349,14 +26287,65 @@
       </p:sp>
       <p:sp>
         <p:nvSpPr>
-          <p:cNvPr id="35" name="Text 33"/>
+          <p:cNvPr id="45" name="img-frame-apple"/>
+          <p:cNvSpPr/>
+          <p:nvPr/>
+        </p:nvSpPr>
+        <p:spPr>
+          <a:xfrm>
+            <a:off x="4005072" y="3163824"/>
+            <a:ext cx="402336" cy="402336"/>
+          </a:xfrm>
+          <a:prstGeom prst="roundRect">
+            <a:avLst>
+              <a:gd name="adj" fmla="val 13636"/>
+            </a:avLst>
+          </a:prstGeom>
+          <a:solidFill>
+            <a:schemeClr val="bg1"/>
+          </a:solidFill>
+          <a:ln w="9525">
+            <a:solidFill>
+              <a:schemeClr val="bg2"/>
+            </a:solidFill>
+            <a:prstDash val="solid"/>
+          </a:ln>
+        </p:spPr>
+      </p:sp>
+      <p:pic>
+        <p:nvPicPr>
+          <p:cNvPr id="46" name="img-apple" descr="apple">    </p:cNvPr>
+          <p:cNvPicPr>
+            <a:picLocks noChangeAspect="1"/>
+          </p:cNvPicPr>
+          <p:nvPr/>
+        </p:nvPicPr>
+        <p:blipFill>
+          <a:blip r:embed="rId6"/>
+          <a:stretch>
+            <a:fillRect/>
+          </a:stretch>
+        </p:blipFill>
+        <p:spPr>
+          <a:xfrm>
+            <a:off x="4057376" y="3216128"/>
+            <a:ext cx="297729" cy="297729"/>
+          </a:xfrm>
+          <a:prstGeom prst="rect">
+            <a:avLst/>
+          </a:prstGeom>
+        </p:spPr>
+      </p:pic>
+      <p:sp>
+        <p:nvSpPr>
+          <p:cNvPr id="47" name="Text 39"/>
           <p:cNvSpPr txBox="1"/>
           <p:nvPr/>
         </p:nvSpPr>
         <p:spPr>
           <a:xfrm>
             <a:off x="2587752" y="3136392"/>
-            <a:ext cx="1819656" cy="411480"/>
+            <a:ext cx="1417320" cy="411480"/>
           </a:xfrm>
           <a:prstGeom prst="rect">
             <a:avLst/>
@@ -24396,14 +26385,14 @@
       </p:sp>
       <p:sp>
         <p:nvSpPr>
-          <p:cNvPr id="36" name="Text 34"/>
+          <p:cNvPr id="48" name="Text 40"/>
           <p:cNvSpPr txBox="1"/>
           <p:nvPr/>
         </p:nvSpPr>
         <p:spPr>
           <a:xfrm>
             <a:off x="2587752" y="3538728"/>
-            <a:ext cx="1819656" cy="219456"/>
+            <a:ext cx="1417320" cy="219456"/>
           </a:xfrm>
           <a:prstGeom prst="rect">
             <a:avLst/>
@@ -24432,7 +26421,7 @@
       </p:sp>
       <p:sp>
         <p:nvSpPr>
-          <p:cNvPr id="37" name="Text 35"/>
+          <p:cNvPr id="49" name="Text 41"/>
           <p:cNvSpPr txBox="1"/>
           <p:nvPr/>
         </p:nvSpPr>
@@ -24468,7 +26457,7 @@
       </p:sp>
       <p:sp>
         <p:nvSpPr>
-          <p:cNvPr id="38" name="card-case-5"/>
+          <p:cNvPr id="50" name="card-case-5"/>
           <p:cNvSpPr/>
           <p:nvPr/>
         </p:nvSpPr>
@@ -24490,7 +26479,7 @@
       </p:sp>
       <p:sp>
         <p:nvSpPr>
-          <p:cNvPr id="39" name="Text 37"/>
+          <p:cNvPr id="51" name="Text 43"/>
           <p:cNvSpPr txBox="1"/>
           <p:nvPr/>
         </p:nvSpPr>
@@ -24537,7 +26526,7 @@
       </p:sp>
       <p:sp>
         <p:nvSpPr>
-          <p:cNvPr id="40" name="card-6"/>
+          <p:cNvPr id="52" name="card-6"/>
           <p:cNvSpPr/>
           <p:nvPr/>
         </p:nvSpPr>
@@ -24559,14 +26548,65 @@
       </p:sp>
       <p:sp>
         <p:nvSpPr>
-          <p:cNvPr id="41" name="Text 39"/>
+          <p:cNvPr id="53" name="img-frame-mcd"/>
+          <p:cNvSpPr/>
+          <p:nvPr/>
+        </p:nvSpPr>
+        <p:spPr>
+          <a:xfrm>
+            <a:off x="6153912" y="3163824"/>
+            <a:ext cx="402336" cy="402336"/>
+          </a:xfrm>
+          <a:prstGeom prst="roundRect">
+            <a:avLst>
+              <a:gd name="adj" fmla="val 13636"/>
+            </a:avLst>
+          </a:prstGeom>
+          <a:solidFill>
+            <a:schemeClr val="bg1"/>
+          </a:solidFill>
+          <a:ln w="9525">
+            <a:solidFill>
+              <a:schemeClr val="bg2"/>
+            </a:solidFill>
+            <a:prstDash val="solid"/>
+          </a:ln>
+        </p:spPr>
+      </p:sp>
+      <p:pic>
+        <p:nvPicPr>
+          <p:cNvPr id="54" name="img-mcd" descr="mcd">    </p:cNvPr>
+          <p:cNvPicPr>
+            <a:picLocks noChangeAspect="1"/>
+          </p:cNvPicPr>
+          <p:nvPr/>
+        </p:nvPicPr>
+        <p:blipFill>
+          <a:blip r:embed="rId7"/>
+          <a:stretch>
+            <a:fillRect/>
+          </a:stretch>
+        </p:blipFill>
+        <p:spPr>
+          <a:xfrm>
+            <a:off x="6206216" y="3216128"/>
+            <a:ext cx="297729" cy="297729"/>
+          </a:xfrm>
+          <a:prstGeom prst="rect">
+            <a:avLst/>
+          </a:prstGeom>
+        </p:spPr>
+      </p:pic>
+      <p:sp>
+        <p:nvSpPr>
+          <p:cNvPr id="55" name="Text 46"/>
           <p:cNvSpPr txBox="1"/>
           <p:nvPr/>
         </p:nvSpPr>
         <p:spPr>
           <a:xfrm>
             <a:off x="4736592" y="3136392"/>
-            <a:ext cx="1819656" cy="411480"/>
+            <a:ext cx="1417320" cy="411480"/>
           </a:xfrm>
           <a:prstGeom prst="rect">
             <a:avLst/>
@@ -24606,14 +26646,14 @@
       </p:sp>
       <p:sp>
         <p:nvSpPr>
-          <p:cNvPr id="42" name="Text 40"/>
+          <p:cNvPr id="56" name="Text 47"/>
           <p:cNvSpPr txBox="1"/>
           <p:nvPr/>
         </p:nvSpPr>
         <p:spPr>
           <a:xfrm>
             <a:off x="4736592" y="3538728"/>
-            <a:ext cx="1819656" cy="219456"/>
+            <a:ext cx="1417320" cy="219456"/>
           </a:xfrm>
           <a:prstGeom prst="rect">
             <a:avLst/>
@@ -24642,7 +26682,7 @@
       </p:sp>
       <p:sp>
         <p:nvSpPr>
-          <p:cNvPr id="43" name="Text 41"/>
+          <p:cNvPr id="57" name="Text 48"/>
           <p:cNvSpPr txBox="1"/>
           <p:nvPr/>
         </p:nvSpPr>
@@ -24678,7 +26718,7 @@
       </p:sp>
       <p:sp>
         <p:nvSpPr>
-          <p:cNvPr id="44" name="card-case-6"/>
+          <p:cNvPr id="58" name="card-case-6"/>
           <p:cNvSpPr/>
           <p:nvPr/>
         </p:nvSpPr>
@@ -24700,7 +26740,7 @@
       </p:sp>
       <p:sp>
         <p:nvSpPr>
-          <p:cNvPr id="45" name="Text 43"/>
+          <p:cNvPr id="59" name="Text 50"/>
           <p:cNvSpPr txBox="1"/>
           <p:nvPr/>
         </p:nvSpPr>
@@ -24747,7 +26787,7 @@
       </p:sp>
       <p:sp>
         <p:nvSpPr>
-          <p:cNvPr id="46" name="card-7"/>
+          <p:cNvPr id="60" name="card-7"/>
           <p:cNvSpPr/>
           <p:nvPr/>
         </p:nvSpPr>
@@ -24769,14 +26809,65 @@
       </p:sp>
       <p:sp>
         <p:nvSpPr>
-          <p:cNvPr id="47" name="Text 45"/>
+          <p:cNvPr id="61" name="img-frame-bluebottle"/>
+          <p:cNvSpPr/>
+          <p:nvPr/>
+        </p:nvSpPr>
+        <p:spPr>
+          <a:xfrm>
+            <a:off x="8302752" y="3163824"/>
+            <a:ext cx="402336" cy="402336"/>
+          </a:xfrm>
+          <a:prstGeom prst="roundRect">
+            <a:avLst>
+              <a:gd name="adj" fmla="val 13636"/>
+            </a:avLst>
+          </a:prstGeom>
+          <a:solidFill>
+            <a:schemeClr val="bg1"/>
+          </a:solidFill>
+          <a:ln w="9525">
+            <a:solidFill>
+              <a:schemeClr val="bg2"/>
+            </a:solidFill>
+            <a:prstDash val="solid"/>
+          </a:ln>
+        </p:spPr>
+      </p:sp>
+      <p:pic>
+        <p:nvPicPr>
+          <p:cNvPr id="62" name="img-bluebottle" descr="bluebottle">    </p:cNvPr>
+          <p:cNvPicPr>
+            <a:picLocks noChangeAspect="1"/>
+          </p:cNvPicPr>
+          <p:nvPr/>
+        </p:nvPicPr>
+        <p:blipFill>
+          <a:blip r:embed="rId8"/>
+          <a:stretch>
+            <a:fillRect/>
+          </a:stretch>
+        </p:blipFill>
+        <p:spPr>
+          <a:xfrm>
+            <a:off x="8355056" y="3216128"/>
+            <a:ext cx="297729" cy="297729"/>
+          </a:xfrm>
+          <a:prstGeom prst="rect">
+            <a:avLst/>
+          </a:prstGeom>
+        </p:spPr>
+      </p:pic>
+      <p:sp>
+        <p:nvSpPr>
+          <p:cNvPr id="63" name="Text 53"/>
           <p:cNvSpPr txBox="1"/>
           <p:nvPr/>
         </p:nvSpPr>
         <p:spPr>
           <a:xfrm>
             <a:off x="6885432" y="3136392"/>
-            <a:ext cx="1819656" cy="411480"/>
+            <a:ext cx="1417320" cy="411480"/>
           </a:xfrm>
           <a:prstGeom prst="rect">
             <a:avLst/>
@@ -24816,14 +26907,14 @@
       </p:sp>
       <p:sp>
         <p:nvSpPr>
-          <p:cNvPr id="48" name="Text 46"/>
+          <p:cNvPr id="64" name="Text 54"/>
           <p:cNvSpPr txBox="1"/>
           <p:nvPr/>
         </p:nvSpPr>
         <p:spPr>
           <a:xfrm>
             <a:off x="6885432" y="3538728"/>
-            <a:ext cx="1819656" cy="219456"/>
+            <a:ext cx="1417320" cy="219456"/>
           </a:xfrm>
           <a:prstGeom prst="rect">
             <a:avLst/>
@@ -24844,7 +26935,7 @@
                   <a:schemeClr val="tx1"/>
                 </a:solidFill>
               </a:rPr>
-              <a:t>Jake Knapp (Google Ventures)</a:t>
+              <a:t>Jake Knapp (GV)</a:t>
             </a:r>
             <a:endParaRPr lang="en-US" sz="900" dirty="0"/>
           </a:p>
@@ -24852,7 +26943,7 @@
       </p:sp>
       <p:sp>
         <p:nvSpPr>
-          <p:cNvPr id="49" name="Text 47"/>
+          <p:cNvPr id="65" name="Text 55"/>
           <p:cNvSpPr txBox="1"/>
           <p:nvPr/>
         </p:nvSpPr>
@@ -24888,7 +26979,7 @@
       </p:sp>
       <p:sp>
         <p:nvSpPr>
-          <p:cNvPr id="50" name="card-case-7"/>
+          <p:cNvPr id="66" name="card-case-7"/>
           <p:cNvSpPr/>
           <p:nvPr/>
         </p:nvSpPr>
@@ -24910,7 +27001,7 @@
       </p:sp>
       <p:sp>
         <p:nvSpPr>
-          <p:cNvPr id="51" name="Text 49"/>
+          <p:cNvPr id="67" name="Text 57"/>
           <p:cNvSpPr txBox="1"/>
           <p:nvPr/>
         </p:nvSpPr>
@@ -24957,7 +27048,7 @@
       </p:sp>
       <p:sp>
         <p:nvSpPr>
-          <p:cNvPr id="52" name="Text 50"/>
+          <p:cNvPr id="68" name="Text 58"/>
           <p:cNvSpPr txBox="1"/>
           <p:nvPr/>
         </p:nvSpPr>

</xml_diff>